<commit_message>
feat: finalize strict template workflow
</commit_message>
<xml_diff>
--- a/examples/review/sample-deck.generated.pptx
+++ b/examples/review/sample-deck.generated.pptx
@@ -16,10 +16,6 @@
     <p:sldId id="264" r:id="rId14"/>
     <p:sldId id="265" r:id="rId15"/>
     <p:sldId id="266" r:id="rId16"/>
-    <p:sldId id="267" r:id="rId17"/>
-    <p:sldId id="268" r:id="rId18"/>
-    <p:sldId id="269" r:id="rId19"/>
-    <p:sldId id="270" r:id="rId20"/>
   </p:sldIdLst>
   <p:sldSz cx="12192000" cy="6858000"/>
   <p:notesSz cx="6858000" cy="9144000"/>
@@ -608,8 +604,8 @@
 </file>
 
 <file path=ppt/slideLayouts/slideLayout10.xml><?xml version="1.0" encoding="utf-8"?>
-<p:sldLayout xmlns:a="http://schemas.openxmlformats.org/drawingml/2006/main" xmlns:r="http://schemas.openxmlformats.org/officeDocument/2006/relationships" xmlns:p="http://schemas.openxmlformats.org/presentationml/2006/main" preserve="1" userDrawn="1" type="cust">
-  <p:cSld name="three_cards_horizontal">
+<p:sldLayout xmlns:a="http://schemas.openxmlformats.org/drawingml/2006/main" xmlns:r="http://schemas.openxmlformats.org/officeDocument/2006/relationships" xmlns:p="http://schemas.openxmlformats.org/presentationml/2006/main" preserve="1" userDrawn="1">
+  <p:cSld name="Title and Vertical Text">
     <p:bg>
       <p:bgPr>
         <a:solidFill>
@@ -634,307 +630,58 @@
       </p:grpSpPr>
       <p:sp>
         <p:nvSpPr>
-          <p:cNvPr id="200" name="deco_h_card1_bg"/>
-          <p:cNvSpPr>
-            <a:spLocks noGrp="1"/>
-          </p:cNvSpPr>
-          <p:nvPr/>
-        </p:nvSpPr>
-        <p:spPr>
-          <a:xfrm>
-            <a:off x="365760" y="980694"/>
-            <a:ext cx="3474720" cy="5472684"/>
-          </a:xfrm>
-          <a:prstGeom prst="rect">
-            <a:avLst/>
-          </a:prstGeom>
-          <a:solidFill>
-            <a:srgbClr val="E8F2FB"/>
-          </a:solidFill>
-          <a:ln>
-            <a:noFill/>
-          </a:ln>
-        </p:spPr>
-        <p:txBody>
-          <a:bodyPr/>
-          <a:lstStyle/>
-          <a:p/>
-        </p:txBody>
-      </p:sp>
-      <p:sp>
-        <p:nvSpPr>
-          <p:cNvPr id="201" name="deco_h_card1_hdr"/>
-          <p:cNvSpPr>
-            <a:spLocks noGrp="1"/>
-          </p:cNvSpPr>
-          <p:nvPr/>
-        </p:nvSpPr>
-        <p:spPr>
-          <a:xfrm>
-            <a:off x="365760" y="980694"/>
-            <a:ext cx="3474720" cy="1028700"/>
-          </a:xfrm>
-          <a:prstGeom prst="rect">
-            <a:avLst/>
-          </a:prstGeom>
-          <a:solidFill>
-            <a:srgbClr val="1C3557"/>
-          </a:solidFill>
-          <a:ln>
-            <a:noFill/>
-          </a:ln>
-        </p:spPr>
-        <p:txBody>
-          <a:bodyPr/>
-          <a:lstStyle/>
-          <a:p/>
-        </p:txBody>
-      </p:sp>
-      <p:sp>
-        <p:nvSpPr>
-          <p:cNvPr id="202" name="deco_h_card1_acc"/>
-          <p:cNvSpPr>
-            <a:spLocks noGrp="1"/>
-          </p:cNvSpPr>
-          <p:nvPr/>
-        </p:nvSpPr>
-        <p:spPr>
-          <a:xfrm>
-            <a:off x="365760" y="980694"/>
-            <a:ext cx="3474720" cy="48006"/>
-          </a:xfrm>
-          <a:prstGeom prst="rect">
-            <a:avLst/>
-          </a:prstGeom>
-          <a:solidFill>
-            <a:srgbClr val="E8763A"/>
-          </a:solidFill>
-          <a:ln>
-            <a:noFill/>
-          </a:ln>
-        </p:spPr>
-        <p:txBody>
-          <a:bodyPr/>
-          <a:lstStyle/>
-          <a:p/>
-        </p:txBody>
-      </p:sp>
-      <p:sp>
-        <p:nvSpPr>
-          <p:cNvPr id="203" name="deco_h_card2_bg"/>
-          <p:cNvSpPr>
-            <a:spLocks noGrp="1"/>
-          </p:cNvSpPr>
-          <p:nvPr/>
-        </p:nvSpPr>
-        <p:spPr>
-          <a:xfrm>
-            <a:off x="4364736" y="980694"/>
-            <a:ext cx="3474720" cy="5472684"/>
-          </a:xfrm>
-          <a:prstGeom prst="rect">
-            <a:avLst/>
-          </a:prstGeom>
-          <a:solidFill>
-            <a:srgbClr val="E8F2FB"/>
-          </a:solidFill>
-          <a:ln>
-            <a:noFill/>
-          </a:ln>
-        </p:spPr>
-        <p:txBody>
-          <a:bodyPr/>
-          <a:lstStyle/>
-          <a:p/>
-        </p:txBody>
-      </p:sp>
-      <p:sp>
-        <p:nvSpPr>
-          <p:cNvPr id="204" name="deco_h_card2_hdr"/>
-          <p:cNvSpPr>
-            <a:spLocks noGrp="1"/>
-          </p:cNvSpPr>
-          <p:nvPr/>
-        </p:nvSpPr>
-        <p:spPr>
-          <a:xfrm>
-            <a:off x="4364736" y="980694"/>
-            <a:ext cx="3474720" cy="1028700"/>
-          </a:xfrm>
-          <a:prstGeom prst="rect">
-            <a:avLst/>
-          </a:prstGeom>
-          <a:solidFill>
-            <a:srgbClr val="1C3557"/>
-          </a:solidFill>
-          <a:ln>
-            <a:noFill/>
-          </a:ln>
-        </p:spPr>
-        <p:txBody>
-          <a:bodyPr/>
-          <a:lstStyle/>
-          <a:p/>
-        </p:txBody>
-      </p:sp>
-      <p:sp>
-        <p:nvSpPr>
-          <p:cNvPr id="205" name="deco_h_card2_acc"/>
-          <p:cNvSpPr>
-            <a:spLocks noGrp="1"/>
-          </p:cNvSpPr>
-          <p:nvPr/>
-        </p:nvSpPr>
-        <p:spPr>
-          <a:xfrm>
-            <a:off x="4364736" y="980694"/>
-            <a:ext cx="3474720" cy="48006"/>
-          </a:xfrm>
-          <a:prstGeom prst="rect">
-            <a:avLst/>
-          </a:prstGeom>
-          <a:solidFill>
-            <a:srgbClr val="E8763A"/>
-          </a:solidFill>
-          <a:ln>
-            <a:noFill/>
-          </a:ln>
-        </p:spPr>
-        <p:txBody>
-          <a:bodyPr/>
-          <a:lstStyle/>
-          <a:p/>
-        </p:txBody>
-      </p:sp>
-      <p:sp>
-        <p:nvSpPr>
-          <p:cNvPr id="206" name="deco_h_card3_bg"/>
-          <p:cNvSpPr>
-            <a:spLocks noGrp="1"/>
-          </p:cNvSpPr>
-          <p:nvPr/>
-        </p:nvSpPr>
-        <p:spPr>
-          <a:xfrm>
-            <a:off x="8351520" y="980694"/>
-            <a:ext cx="3474720" cy="5472684"/>
-          </a:xfrm>
-          <a:prstGeom prst="rect">
-            <a:avLst/>
-          </a:prstGeom>
-          <a:solidFill>
-            <a:srgbClr val="E8F2FB"/>
-          </a:solidFill>
-          <a:ln>
-            <a:noFill/>
-          </a:ln>
-        </p:spPr>
-        <p:txBody>
-          <a:bodyPr/>
-          <a:lstStyle/>
-          <a:p/>
-        </p:txBody>
-      </p:sp>
-      <p:sp>
-        <p:nvSpPr>
-          <p:cNvPr id="207" name="deco_h_card3_hdr"/>
-          <p:cNvSpPr>
-            <a:spLocks noGrp="1"/>
-          </p:cNvSpPr>
-          <p:nvPr/>
-        </p:nvSpPr>
-        <p:spPr>
-          <a:xfrm>
-            <a:off x="8351520" y="980694"/>
-            <a:ext cx="3474720" cy="1028700"/>
-          </a:xfrm>
-          <a:prstGeom prst="rect">
-            <a:avLst/>
-          </a:prstGeom>
-          <a:solidFill>
-            <a:srgbClr val="1C3557"/>
-          </a:solidFill>
-          <a:ln>
-            <a:noFill/>
-          </a:ln>
-        </p:spPr>
-        <p:txBody>
-          <a:bodyPr/>
-          <a:lstStyle/>
-          <a:p/>
-        </p:txBody>
-      </p:sp>
-      <p:sp>
-        <p:nvSpPr>
-          <p:cNvPr id="208" name="deco_h_card3_acc"/>
-          <p:cNvSpPr>
-            <a:spLocks noGrp="1"/>
-          </p:cNvSpPr>
-          <p:nvPr/>
-        </p:nvSpPr>
-        <p:spPr>
-          <a:xfrm>
-            <a:off x="8351520" y="980694"/>
-            <a:ext cx="3474720" cy="48006"/>
-          </a:xfrm>
-          <a:prstGeom prst="rect">
-            <a:avLst/>
-          </a:prstGeom>
-          <a:solidFill>
-            <a:srgbClr val="E8763A"/>
-          </a:solidFill>
-          <a:ln>
-            <a:noFill/>
-          </a:ln>
-        </p:spPr>
-        <p:txBody>
-          <a:bodyPr/>
-          <a:lstStyle/>
-          <a:p/>
-        </p:txBody>
-      </p:sp>
-      <p:sp>
-        <p:nvSpPr>
-          <p:cNvPr id="8" name="タイトル 7">
-            <a:extLst>
-              <a:ext uri="{FF2B5EF4-FFF2-40B4-BE49-F238E27FC236}">
-                <a16:creationId xmlns:a16="http://schemas.microsoft.com/office/drawing/2014/main" id="{8A4D2959-DC66-A124-52B8-8E8467A7D32E}"/>
-              </a:ext>
-            </a:extLst>
-          </p:cNvPr>
-          <p:cNvSpPr>
-            <a:spLocks noGrp="1"/>
-          </p:cNvSpPr>
-          <p:nvPr>
-            <p:ph type="title"/>
-          </p:nvPr>
-        </p:nvSpPr>
-        <p:spPr>
-          <a:xfrm>
-            <a:off x="231648" y="219456"/>
-            <a:ext cx="11728704" cy="644652"/>
-          </a:xfrm>
-        </p:spPr>
-        <p:txBody>
-          <a:bodyPr/>
-          <a:lstStyle/>
-          <a:p>
-            <a:r>
-              <a:rPr kumimoji="1" lang="ja-JP" altLang="en-US"/>
-              <a:t>マスター タイトルの書式設定</a:t>
-            </a:r>
-          </a:p>
-        </p:txBody>
-      </p:sp>
-      <p:sp>
-        <p:nvSpPr>
-          <p:cNvPr id="9" name="日付プレースホルダー 8">
-            <a:extLst>
-              <a:ext uri="{FF2B5EF4-FFF2-40B4-BE49-F238E27FC236}">
-                <a16:creationId xmlns:a16="http://schemas.microsoft.com/office/drawing/2014/main" id="{AC78EFE3-FFBC-52AC-793F-A5AC5CEFBAE0}"/>
-              </a:ext>
-            </a:extLst>
-          </p:cNvPr>
+          <p:cNvPr id="3" name="Vertical Text Placeholder 2"/>
+          <p:cNvSpPr>
+            <a:spLocks noGrp="1"/>
+          </p:cNvSpPr>
+          <p:nvPr>
+            <p:ph type="body" orient="vert" idx="1"/>
+          </p:nvPr>
+        </p:nvSpPr>
+        <p:spPr/>
+        <p:txBody>
+          <a:bodyPr vert="eaVert"/>
+          <a:lstStyle/>
+          <a:p>
+            <a:pPr lvl="0"/>
+            <a:r>
+              <a:rPr lang="en-US"/>
+              <a:t>Click to edit Master text styles</a:t>
+            </a:r>
+          </a:p>
+          <a:p>
+            <a:pPr lvl="1"/>
+            <a:r>
+              <a:rPr lang="en-US"/>
+              <a:t>Second level</a:t>
+            </a:r>
+          </a:p>
+          <a:p>
+            <a:pPr lvl="2"/>
+            <a:r>
+              <a:rPr lang="en-US"/>
+              <a:t>Third level</a:t>
+            </a:r>
+          </a:p>
+          <a:p>
+            <a:pPr lvl="3"/>
+            <a:r>
+              <a:rPr lang="en-US"/>
+              <a:t>Fourth level</a:t>
+            </a:r>
+          </a:p>
+          <a:p>
+            <a:pPr lvl="4"/>
+            <a:r>
+              <a:rPr lang="en-US"/>
+              <a:t>Fifth level</a:t>
+            </a:r>
+          </a:p>
+        </p:txBody>
+      </p:sp>
+      <p:sp>
+        <p:nvSpPr>
+          <p:cNvPr id="4" name="Date Placeholder 3"/>
           <p:cNvSpPr>
             <a:spLocks noGrp="1"/>
           </p:cNvSpPr>
@@ -957,13 +704,7 @@
       </p:sp>
       <p:sp>
         <p:nvSpPr>
-          <p:cNvPr id="10" name="フッター プレースホルダー 9">
-            <a:extLst>
-              <a:ext uri="{FF2B5EF4-FFF2-40B4-BE49-F238E27FC236}">
-                <a16:creationId xmlns:a16="http://schemas.microsoft.com/office/drawing/2014/main" id="{2885C4CB-8898-EE25-076E-20BC39DFAA4B}"/>
-              </a:ext>
-            </a:extLst>
-          </p:cNvPr>
+          <p:cNvPr id="5" name="Footer Placeholder 4"/>
           <p:cNvSpPr>
             <a:spLocks noGrp="1"/>
           </p:cNvSpPr>
@@ -976,19 +717,13 @@
           <a:bodyPr/>
           <a:lstStyle/>
           <a:p>
-            <a:endParaRPr lang="en-US" dirty="0"/>
-          </a:p>
-        </p:txBody>
-      </p:sp>
-      <p:sp>
-        <p:nvSpPr>
-          <p:cNvPr id="11" name="スライド番号プレースホルダー 10">
-            <a:extLst>
-              <a:ext uri="{FF2B5EF4-FFF2-40B4-BE49-F238E27FC236}">
-                <a16:creationId xmlns:a16="http://schemas.microsoft.com/office/drawing/2014/main" id="{79D36539-24EF-59E1-CB5B-33D4B26D742C}"/>
-              </a:ext>
-            </a:extLst>
-          </p:cNvPr>
+            <a:endParaRPr lang="en-US"/>
+          </a:p>
+        </p:txBody>
+      </p:sp>
+      <p:sp>
+        <p:nvSpPr>
+          <p:cNvPr id="6" name="Slide Number Placeholder 5"/>
           <p:cNvSpPr>
             <a:spLocks noGrp="1"/>
           </p:cNvSpPr>
@@ -1011,10 +746,10 @@
       </p:sp>
       <p:sp>
         <p:nvSpPr>
-          <p:cNvPr id="13" name="slot__card_1_combined_text">
+          <p:cNvPr id="7" name="タイトル 6">
             <a:extLst>
               <a:ext uri="{FF2B5EF4-FFF2-40B4-BE49-F238E27FC236}">
-                <a16:creationId xmlns:a16="http://schemas.microsoft.com/office/drawing/2014/main" id="{23D794FD-7998-B263-7A33-0D9A529D97EE}"/>
+                <a16:creationId xmlns:a16="http://schemas.microsoft.com/office/drawing/2014/main" id="{77F5274A-DA0B-755A-88F2-D3159180EEF9}"/>
               </a:ext>
             </a:extLst>
           </p:cNvPr>
@@ -1022,470 +757,18 @@
             <a:spLocks noGrp="1"/>
           </p:cNvSpPr>
           <p:nvPr>
-            <p:ph sz="quarter" idx="13" type="obj"/>
-          </p:nvPr>
-        </p:nvSpPr>
-        <p:spPr>
-          <a:xfrm>
-            <a:off x="463296" y="2064258"/>
-            <a:ext cx="3279648" cy="4389120"/>
-          </a:xfrm>
-        </p:spPr>
-        <p:txBody>
-          <a:bodyPr/>
-          <a:lstStyle/>
-          <a:p>
-            <a:pPr lvl="0"/>
-            <a:r>
-              <a:rPr kumimoji="1" lang="ja-JP" altLang="en-US"/>
-              <a:t>マスター テキストの書式設定</a:t>
-            </a:r>
-          </a:p>
-          <a:p>
-            <a:pPr lvl="1"/>
-            <a:r>
-              <a:rPr kumimoji="1" lang="ja-JP" altLang="en-US"/>
-              <a:t>第 </a:t>
-            </a:r>
-            <a:r>
-              <a:rPr kumimoji="1" lang="en-US" altLang="ja-JP"/>
-              <a:t>2 </a:t>
-            </a:r>
-            <a:r>
-              <a:rPr kumimoji="1" lang="ja-JP" altLang="en-US"/>
-              <a:t>レベル</a:t>
-            </a:r>
-          </a:p>
-          <a:p>
-            <a:pPr lvl="2"/>
-            <a:r>
-              <a:rPr kumimoji="1" lang="ja-JP" altLang="en-US"/>
-              <a:t>第 </a:t>
-            </a:r>
-            <a:r>
-              <a:rPr kumimoji="1" lang="en-US" altLang="ja-JP"/>
-              <a:t>3 </a:t>
-            </a:r>
-            <a:r>
-              <a:rPr kumimoji="1" lang="ja-JP" altLang="en-US"/>
-              <a:t>レベル</a:t>
-            </a:r>
-          </a:p>
-          <a:p>
-            <a:pPr lvl="3"/>
-            <a:r>
-              <a:rPr kumimoji="1" lang="ja-JP" altLang="en-US"/>
-              <a:t>第 </a:t>
-            </a:r>
-            <a:r>
-              <a:rPr kumimoji="1" lang="en-US" altLang="ja-JP"/>
-              <a:t>4 </a:t>
-            </a:r>
-            <a:r>
-              <a:rPr kumimoji="1" lang="ja-JP" altLang="en-US"/>
-              <a:t>レベル</a:t>
-            </a:r>
-          </a:p>
-          <a:p>
-            <a:pPr lvl="4"/>
-            <a:r>
-              <a:rPr kumimoji="1" lang="ja-JP" altLang="en-US"/>
-              <a:t>第 </a:t>
-            </a:r>
-            <a:r>
-              <a:rPr kumimoji="1" lang="en-US" altLang="ja-JP"/>
-              <a:t>5 </a:t>
-            </a:r>
-            <a:r>
-              <a:rPr kumimoji="1" lang="ja-JP" altLang="en-US"/>
-              <a:t>レベル</a:t>
-            </a:r>
-          </a:p>
-        </p:txBody>
-      </p:sp>
-      <p:sp>
-        <p:nvSpPr>
-          <p:cNvPr id="15" name="slot__card_2_combined_text">
-            <a:extLst>
-              <a:ext uri="{FF2B5EF4-FFF2-40B4-BE49-F238E27FC236}">
-                <a16:creationId xmlns:a16="http://schemas.microsoft.com/office/drawing/2014/main" id="{CE5D3923-D828-BFFF-25F1-02538CEB89C0}"/>
-              </a:ext>
-            </a:extLst>
-          </p:cNvPr>
-          <p:cNvSpPr>
-            <a:spLocks noGrp="1"/>
-          </p:cNvSpPr>
-          <p:nvPr>
-            <p:ph sz="quarter" idx="14" type="obj"/>
-          </p:nvPr>
-        </p:nvSpPr>
-        <p:spPr>
-          <a:xfrm>
-            <a:off x="4462272" y="2064258"/>
-            <a:ext cx="3279648" cy="4389120"/>
-          </a:xfrm>
-        </p:spPr>
-        <p:txBody>
-          <a:bodyPr/>
-          <a:lstStyle/>
-          <a:p>
-            <a:pPr lvl="0"/>
-            <a:r>
-              <a:rPr kumimoji="1" lang="ja-JP" altLang="en-US"/>
-              <a:t>マスター テキストの書式設定</a:t>
-            </a:r>
-          </a:p>
-          <a:p>
-            <a:pPr lvl="1"/>
-            <a:r>
-              <a:rPr kumimoji="1" lang="ja-JP" altLang="en-US"/>
-              <a:t>第 </a:t>
-            </a:r>
-            <a:r>
-              <a:rPr kumimoji="1" lang="en-US" altLang="ja-JP"/>
-              <a:t>2 </a:t>
-            </a:r>
-            <a:r>
-              <a:rPr kumimoji="1" lang="ja-JP" altLang="en-US"/>
-              <a:t>レベル</a:t>
-            </a:r>
-          </a:p>
-          <a:p>
-            <a:pPr lvl="2"/>
-            <a:r>
-              <a:rPr kumimoji="1" lang="ja-JP" altLang="en-US"/>
-              <a:t>第 </a:t>
-            </a:r>
-            <a:r>
-              <a:rPr kumimoji="1" lang="en-US" altLang="ja-JP"/>
-              <a:t>3 </a:t>
-            </a:r>
-            <a:r>
-              <a:rPr kumimoji="1" lang="ja-JP" altLang="en-US"/>
-              <a:t>レベル</a:t>
-            </a:r>
-          </a:p>
-          <a:p>
-            <a:pPr lvl="3"/>
-            <a:r>
-              <a:rPr kumimoji="1" lang="ja-JP" altLang="en-US"/>
-              <a:t>第 </a:t>
-            </a:r>
-            <a:r>
-              <a:rPr kumimoji="1" lang="en-US" altLang="ja-JP"/>
-              <a:t>4 </a:t>
-            </a:r>
-            <a:r>
-              <a:rPr kumimoji="1" lang="ja-JP" altLang="en-US"/>
-              <a:t>レベル</a:t>
-            </a:r>
-          </a:p>
-          <a:p>
-            <a:pPr lvl="4"/>
-            <a:r>
-              <a:rPr kumimoji="1" lang="ja-JP" altLang="en-US"/>
-              <a:t>第 </a:t>
-            </a:r>
-            <a:r>
-              <a:rPr kumimoji="1" lang="en-US" altLang="ja-JP"/>
-              <a:t>5 </a:t>
-            </a:r>
-            <a:r>
-              <a:rPr kumimoji="1" lang="ja-JP" altLang="en-US"/>
-              <a:t>レベル</a:t>
-            </a:r>
-          </a:p>
-        </p:txBody>
-      </p:sp>
-      <p:sp>
-        <p:nvSpPr>
-          <p:cNvPr id="16" name="slot__card_3_combined_text">
-            <a:extLst>
-              <a:ext uri="{FF2B5EF4-FFF2-40B4-BE49-F238E27FC236}">
-                <a16:creationId xmlns:a16="http://schemas.microsoft.com/office/drawing/2014/main" id="{CE5D3923-D828-BFFF-25F1-02538CEB89C0}"/>
-              </a:ext>
-            </a:extLst>
-          </p:cNvPr>
-          <p:cNvSpPr>
-            <a:spLocks noGrp="1"/>
-          </p:cNvSpPr>
-          <p:nvPr>
-            <p:ph sz="quarter" idx="15" type="obj"/>
-          </p:nvPr>
-        </p:nvSpPr>
-        <p:spPr>
-          <a:xfrm>
-            <a:off x="8449056" y="2064258"/>
-            <a:ext cx="3279648" cy="4389120"/>
-          </a:xfrm>
-        </p:spPr>
-        <p:txBody>
-          <a:bodyPr/>
-          <a:lstStyle/>
-          <a:p>
-            <a:pPr lvl="0"/>
-            <a:r>
-              <a:rPr kumimoji="1" lang="ja-JP" altLang="en-US"/>
-              <a:t>マスター テキストの書式設定</a:t>
-            </a:r>
-          </a:p>
-          <a:p>
-            <a:pPr lvl="1"/>
-            <a:r>
-              <a:rPr kumimoji="1" lang="ja-JP" altLang="en-US"/>
-              <a:t>第 </a:t>
-            </a:r>
-            <a:r>
-              <a:rPr kumimoji="1" lang="en-US" altLang="ja-JP"/>
-              <a:t>2 </a:t>
-            </a:r>
-            <a:r>
-              <a:rPr kumimoji="1" lang="ja-JP" altLang="en-US"/>
-              <a:t>レベル</a:t>
-            </a:r>
-          </a:p>
-          <a:p>
-            <a:pPr lvl="2"/>
-            <a:r>
-              <a:rPr kumimoji="1" lang="ja-JP" altLang="en-US"/>
-              <a:t>第 </a:t>
-            </a:r>
-            <a:r>
-              <a:rPr kumimoji="1" lang="en-US" altLang="ja-JP"/>
-              <a:t>3 </a:t>
-            </a:r>
-            <a:r>
-              <a:rPr kumimoji="1" lang="ja-JP" altLang="en-US"/>
-              <a:t>レベル</a:t>
-            </a:r>
-          </a:p>
-          <a:p>
-            <a:pPr lvl="3"/>
-            <a:r>
-              <a:rPr kumimoji="1" lang="ja-JP" altLang="en-US"/>
-              <a:t>第 </a:t>
-            </a:r>
-            <a:r>
-              <a:rPr kumimoji="1" lang="en-US" altLang="ja-JP"/>
-              <a:t>4 </a:t>
-            </a:r>
-            <a:r>
-              <a:rPr kumimoji="1" lang="ja-JP" altLang="en-US"/>
-              <a:t>レベル</a:t>
-            </a:r>
-          </a:p>
-          <a:p>
-            <a:pPr lvl="4"/>
-            <a:r>
-              <a:rPr kumimoji="1" lang="ja-JP" altLang="en-US"/>
-              <a:t>第 </a:t>
-            </a:r>
-            <a:r>
-              <a:rPr kumimoji="1" lang="en-US" altLang="ja-JP"/>
-              <a:t>5 </a:t>
-            </a:r>
-            <a:r>
-              <a:rPr kumimoji="1" lang="ja-JP" altLang="en-US"/>
-              <a:t>レベル</a:t>
-            </a:r>
-          </a:p>
-        </p:txBody>
-      </p:sp>
-      <p:sp>
-        <p:nvSpPr>
-          <p:cNvPr id="17" name="slot__card_1_icon"/>
-          <p:cNvSpPr>
-            <a:spLocks noGrp="1"/>
-          </p:cNvSpPr>
-          <p:nvPr>
-            <p:ph type="pic" idx="16"/>
-          </p:nvPr>
-        </p:nvSpPr>
-        <p:spPr>
-          <a:xfrm>
-            <a:off x="1493520" y="1117854"/>
-            <a:ext cx="1219200" cy="754380"/>
-          </a:xfrm>
-          <a:noFill/>
-          <a:ln>
-            <a:noFill/>
-          </a:ln>
-        </p:spPr>
-        <p:txBody>
-          <a:bodyPr wrap="square" lIns="0" tIns="0" rIns="0" bIns="0" anchor="t"/>
-          <a:lstStyle>
-            <a:lvl1pPr marL="0" indent="0">
-              <a:buNone/>
-              <a:defRPr sz="3200"/>
-            </a:lvl1pPr>
-            <a:lvl2pPr marL="457200" indent="0">
-              <a:buNone/>
-              <a:defRPr sz="2800"/>
-            </a:lvl2pPr>
-            <a:lvl3pPr marL="914400" indent="0">
-              <a:buNone/>
-              <a:defRPr sz="2400"/>
-            </a:lvl3pPr>
-            <a:lvl4pPr marL="1371600" indent="0">
-              <a:buNone/>
-              <a:defRPr sz="2000"/>
-            </a:lvl4pPr>
-            <a:lvl5pPr marL="1828800" indent="0">
-              <a:buNone/>
-              <a:defRPr sz="2000"/>
-            </a:lvl5pPr>
-            <a:lvl6pPr marL="2286000" indent="0">
-              <a:buNone/>
-              <a:defRPr sz="2000"/>
-            </a:lvl6pPr>
-            <a:lvl7pPr marL="2743200" indent="0">
-              <a:buNone/>
-              <a:defRPr sz="2000"/>
-            </a:lvl7pPr>
-            <a:lvl8pPr marL="3200400" indent="0">
-              <a:buNone/>
-              <a:defRPr sz="2000"/>
-            </a:lvl8pPr>
-            <a:lvl9pPr marL="3657600" indent="0">
-              <a:buNone/>
-              <a:defRPr sz="2000"/>
-            </a:lvl9pPr>
-          </a:lstStyle>
-          <a:p>
-            <a:pPr algn="l"/>
-            <a:endParaRPr lang="en-US"/>
-          </a:p>
-        </p:txBody>
-      </p:sp>
-      <p:sp>
-        <p:nvSpPr>
-          <p:cNvPr id="18" name="slot__card_2_icon"/>
-          <p:cNvSpPr>
-            <a:spLocks noGrp="1"/>
-          </p:cNvSpPr>
-          <p:nvPr>
-            <p:ph type="pic" idx="17"/>
-          </p:nvPr>
-        </p:nvSpPr>
-        <p:spPr>
-          <a:xfrm>
-            <a:off x="5492496" y="1117854"/>
-            <a:ext cx="1219200" cy="754380"/>
-          </a:xfrm>
-          <a:noFill/>
-          <a:ln>
-            <a:noFill/>
-          </a:ln>
-        </p:spPr>
-        <p:txBody>
-          <a:bodyPr wrap="square" lIns="0" tIns="0" rIns="0" bIns="0" anchor="t"/>
-          <a:lstStyle>
-            <a:lvl1pPr marL="0" indent="0">
-              <a:buNone/>
-              <a:defRPr sz="3200"/>
-            </a:lvl1pPr>
-            <a:lvl2pPr marL="457200" indent="0">
-              <a:buNone/>
-              <a:defRPr sz="2800"/>
-            </a:lvl2pPr>
-            <a:lvl3pPr marL="914400" indent="0">
-              <a:buNone/>
-              <a:defRPr sz="2400"/>
-            </a:lvl3pPr>
-            <a:lvl4pPr marL="1371600" indent="0">
-              <a:buNone/>
-              <a:defRPr sz="2000"/>
-            </a:lvl4pPr>
-            <a:lvl5pPr marL="1828800" indent="0">
-              <a:buNone/>
-              <a:defRPr sz="2000"/>
-            </a:lvl5pPr>
-            <a:lvl6pPr marL="2286000" indent="0">
-              <a:buNone/>
-              <a:defRPr sz="2000"/>
-            </a:lvl6pPr>
-            <a:lvl7pPr marL="2743200" indent="0">
-              <a:buNone/>
-              <a:defRPr sz="2000"/>
-            </a:lvl7pPr>
-            <a:lvl8pPr marL="3200400" indent="0">
-              <a:buNone/>
-              <a:defRPr sz="2000"/>
-            </a:lvl8pPr>
-            <a:lvl9pPr marL="3657600" indent="0">
-              <a:buNone/>
-              <a:defRPr sz="2000"/>
-            </a:lvl9pPr>
-          </a:lstStyle>
-          <a:p>
-            <a:pPr algn="l"/>
-            <a:endParaRPr lang="en-US"/>
-          </a:p>
-        </p:txBody>
-      </p:sp>
-      <p:sp>
-        <p:nvSpPr>
-          <p:cNvPr id="19" name="slot__card_3_icon"/>
-          <p:cNvSpPr>
-            <a:spLocks noGrp="1"/>
-          </p:cNvSpPr>
-          <p:nvPr>
-            <p:ph type="pic" idx="18"/>
-          </p:nvPr>
-        </p:nvSpPr>
-        <p:spPr>
-          <a:xfrm>
-            <a:off x="9479280" y="1117854"/>
-            <a:ext cx="1219200" cy="754380"/>
-          </a:xfrm>
-          <a:noFill/>
-          <a:ln>
-            <a:noFill/>
-          </a:ln>
-        </p:spPr>
-        <p:txBody>
-          <a:bodyPr wrap="square" lIns="0" tIns="0" rIns="0" bIns="0" anchor="t"/>
-          <a:lstStyle>
-            <a:lvl1pPr marL="0" indent="0">
-              <a:buNone/>
-              <a:defRPr sz="3200"/>
-            </a:lvl1pPr>
-            <a:lvl2pPr marL="457200" indent="0">
-              <a:buNone/>
-              <a:defRPr sz="2800"/>
-            </a:lvl2pPr>
-            <a:lvl3pPr marL="914400" indent="0">
-              <a:buNone/>
-              <a:defRPr sz="2400"/>
-            </a:lvl3pPr>
-            <a:lvl4pPr marL="1371600" indent="0">
-              <a:buNone/>
-              <a:defRPr sz="2000"/>
-            </a:lvl4pPr>
-            <a:lvl5pPr marL="1828800" indent="0">
-              <a:buNone/>
-              <a:defRPr sz="2000"/>
-            </a:lvl5pPr>
-            <a:lvl6pPr marL="2286000" indent="0">
-              <a:buNone/>
-              <a:defRPr sz="2000"/>
-            </a:lvl6pPr>
-            <a:lvl7pPr marL="2743200" indent="0">
-              <a:buNone/>
-              <a:defRPr sz="2000"/>
-            </a:lvl7pPr>
-            <a:lvl8pPr marL="3200400" indent="0">
-              <a:buNone/>
-              <a:defRPr sz="2000"/>
-            </a:lvl8pPr>
-            <a:lvl9pPr marL="3657600" indent="0">
-              <a:buNone/>
-              <a:defRPr sz="2000"/>
-            </a:lvl9pPr>
-          </a:lstStyle>
-          <a:p>
-            <a:pPr algn="l"/>
-            <a:endParaRPr lang="en-US"/>
+            <p:ph type="title"/>
+          </p:nvPr>
+        </p:nvSpPr>
+        <p:spPr/>
+        <p:txBody>
+          <a:bodyPr/>
+          <a:lstStyle/>
+          <a:p>
+            <a:r>
+              <a:rPr kumimoji="1" lang="ja-JP" altLang="en-US"/>
+              <a:t>マスター タイトルの書式設定</a:t>
+            </a:r>
           </a:p>
         </p:txBody>
       </p:sp>
@@ -1529,7 +812,7 @@
       </p:grpSpPr>
       <p:sp>
         <p:nvSpPr>
-          <p:cNvPr id="200" name="deco_v_strip1_bg"/>
+          <p:cNvPr id="200" name="deco_h_card1_bg"/>
           <p:cNvSpPr>
             <a:spLocks noGrp="1"/>
           </p:cNvSpPr>
@@ -1537,8 +820,8 @@
         </p:nvSpPr>
         <p:spPr>
           <a:xfrm>
-            <a:off x="243840" y="1014984"/>
-            <a:ext cx="11704320" cy="1536192"/>
+            <a:off x="365760" y="980694"/>
+            <a:ext cx="3474720" cy="5472684"/>
           </a:xfrm>
           <a:prstGeom prst="rect">
             <a:avLst/>
@@ -1558,7 +841,7 @@
       </p:sp>
       <p:sp>
         <p:nvSpPr>
-          <p:cNvPr id="201" name="deco_v_strip1_bar"/>
+          <p:cNvPr id="201" name="deco_h_card1_hdr"/>
           <p:cNvSpPr>
             <a:spLocks noGrp="1"/>
           </p:cNvSpPr>
@@ -1566,8 +849,8 @@
         </p:nvSpPr>
         <p:spPr>
           <a:xfrm>
-            <a:off x="243840" y="1014984"/>
-            <a:ext cx="121920" cy="1536192"/>
+            <a:off x="365760" y="980694"/>
+            <a:ext cx="3474720" cy="1028700"/>
           </a:xfrm>
           <a:prstGeom prst="rect">
             <a:avLst/>
@@ -1587,7 +870,7 @@
       </p:sp>
       <p:sp>
         <p:nvSpPr>
-          <p:cNvPr id="202" name="deco_v_strip2_bg"/>
+          <p:cNvPr id="202" name="deco_h_card1_acc"/>
           <p:cNvSpPr>
             <a:spLocks noGrp="1"/>
           </p:cNvSpPr>
@@ -1595,8 +878,37 @@
         </p:nvSpPr>
         <p:spPr>
           <a:xfrm>
-            <a:off x="243840" y="2743200"/>
-            <a:ext cx="11704320" cy="1536192"/>
+            <a:off x="365760" y="980694"/>
+            <a:ext cx="3474720" cy="48006"/>
+          </a:xfrm>
+          <a:prstGeom prst="rect">
+            <a:avLst/>
+          </a:prstGeom>
+          <a:solidFill>
+            <a:srgbClr val="E8763A"/>
+          </a:solidFill>
+          <a:ln>
+            <a:noFill/>
+          </a:ln>
+        </p:spPr>
+        <p:txBody>
+          <a:bodyPr/>
+          <a:lstStyle/>
+          <a:p/>
+        </p:txBody>
+      </p:sp>
+      <p:sp>
+        <p:nvSpPr>
+          <p:cNvPr id="203" name="deco_h_card2_bg"/>
+          <p:cNvSpPr>
+            <a:spLocks noGrp="1"/>
+          </p:cNvSpPr>
+          <p:nvPr/>
+        </p:nvSpPr>
+        <p:spPr>
+          <a:xfrm>
+            <a:off x="4364736" y="980694"/>
+            <a:ext cx="3474720" cy="5472684"/>
           </a:xfrm>
           <a:prstGeom prst="rect">
             <a:avLst/>
@@ -1616,7 +928,7 @@
       </p:sp>
       <p:sp>
         <p:nvSpPr>
-          <p:cNvPr id="203" name="deco_v_strip2_bar"/>
+          <p:cNvPr id="204" name="deco_h_card2_hdr"/>
           <p:cNvSpPr>
             <a:spLocks noGrp="1"/>
           </p:cNvSpPr>
@@ -1624,8 +936,8 @@
         </p:nvSpPr>
         <p:spPr>
           <a:xfrm>
-            <a:off x="243840" y="2743200"/>
-            <a:ext cx="121920" cy="1536192"/>
+            <a:off x="4364736" y="980694"/>
+            <a:ext cx="3474720" cy="1028700"/>
           </a:xfrm>
           <a:prstGeom prst="rect">
             <a:avLst/>
@@ -1645,7 +957,7 @@
       </p:sp>
       <p:sp>
         <p:nvSpPr>
-          <p:cNvPr id="204" name="deco_v_strip3_bg"/>
+          <p:cNvPr id="205" name="deco_h_card2_acc"/>
           <p:cNvSpPr>
             <a:spLocks noGrp="1"/>
           </p:cNvSpPr>
@@ -1653,8 +965,37 @@
         </p:nvSpPr>
         <p:spPr>
           <a:xfrm>
-            <a:off x="243840" y="4471416"/>
-            <a:ext cx="11704320" cy="1536192"/>
+            <a:off x="4364736" y="980694"/>
+            <a:ext cx="3474720" cy="48006"/>
+          </a:xfrm>
+          <a:prstGeom prst="rect">
+            <a:avLst/>
+          </a:prstGeom>
+          <a:solidFill>
+            <a:srgbClr val="E8763A"/>
+          </a:solidFill>
+          <a:ln>
+            <a:noFill/>
+          </a:ln>
+        </p:spPr>
+        <p:txBody>
+          <a:bodyPr/>
+          <a:lstStyle/>
+          <a:p/>
+        </p:txBody>
+      </p:sp>
+      <p:sp>
+        <p:nvSpPr>
+          <p:cNvPr id="206" name="deco_h_card3_bg"/>
+          <p:cNvSpPr>
+            <a:spLocks noGrp="1"/>
+          </p:cNvSpPr>
+          <p:nvPr/>
+        </p:nvSpPr>
+        <p:spPr>
+          <a:xfrm>
+            <a:off x="8351520" y="980694"/>
+            <a:ext cx="3474720" cy="5472684"/>
           </a:xfrm>
           <a:prstGeom prst="rect">
             <a:avLst/>
@@ -1674,7 +1015,7 @@
       </p:sp>
       <p:sp>
         <p:nvSpPr>
-          <p:cNvPr id="205" name="deco_v_strip3_bar"/>
+          <p:cNvPr id="207" name="deco_h_card3_hdr"/>
           <p:cNvSpPr>
             <a:spLocks noGrp="1"/>
           </p:cNvSpPr>
@@ -1682,8 +1023,8 @@
         </p:nvSpPr>
         <p:spPr>
           <a:xfrm>
-            <a:off x="243840" y="4471416"/>
-            <a:ext cx="121920" cy="1536192"/>
+            <a:off x="8351520" y="980694"/>
+            <a:ext cx="3474720" cy="1028700"/>
           </a:xfrm>
           <a:prstGeom prst="rect">
             <a:avLst/>
@@ -1703,6 +1044,35 @@
       </p:sp>
       <p:sp>
         <p:nvSpPr>
+          <p:cNvPr id="208" name="deco_h_card3_acc"/>
+          <p:cNvSpPr>
+            <a:spLocks noGrp="1"/>
+          </p:cNvSpPr>
+          <p:nvPr/>
+        </p:nvSpPr>
+        <p:spPr>
+          <a:xfrm>
+            <a:off x="8351520" y="980694"/>
+            <a:ext cx="3474720" cy="48006"/>
+          </a:xfrm>
+          <a:prstGeom prst="rect">
+            <a:avLst/>
+          </a:prstGeom>
+          <a:solidFill>
+            <a:srgbClr val="E8763A"/>
+          </a:solidFill>
+          <a:ln>
+            <a:noFill/>
+          </a:ln>
+        </p:spPr>
+        <p:txBody>
+          <a:bodyPr/>
+          <a:lstStyle/>
+          <a:p/>
+        </p:txBody>
+      </p:sp>
+      <p:sp>
+        <p:nvSpPr>
           <p:cNvPr id="8" name="タイトル 7">
             <a:extLst>
               <a:ext uri="{FF2B5EF4-FFF2-40B4-BE49-F238E27FC236}">
@@ -1835,8 +1205,8 @@
         </p:nvSpPr>
         <p:spPr>
           <a:xfrm>
-            <a:off x="1524000" y="1234440"/>
-            <a:ext cx="10302240" cy="1097280"/>
+            <a:off x="463296" y="2064258"/>
+            <a:ext cx="3279648" cy="4389120"/>
           </a:xfrm>
         </p:spPr>
         <p:txBody>
@@ -1929,8 +1299,8 @@
         </p:nvSpPr>
         <p:spPr>
           <a:xfrm>
-            <a:off x="1524000" y="2962656"/>
-            <a:ext cx="10302240" cy="1097280"/>
+            <a:off x="4462272" y="2064258"/>
+            <a:ext cx="3279648" cy="4389120"/>
           </a:xfrm>
         </p:spPr>
         <p:txBody>
@@ -2023,8 +1393,8 @@
         </p:nvSpPr>
         <p:spPr>
           <a:xfrm>
-            <a:off x="1524000" y="4690872"/>
-            <a:ext cx="10302240" cy="1097280"/>
+            <a:off x="8449056" y="2064258"/>
+            <a:ext cx="3279648" cy="4389120"/>
           </a:xfrm>
         </p:spPr>
         <p:txBody>
@@ -2111,8 +1481,8 @@
         </p:nvSpPr>
         <p:spPr>
           <a:xfrm>
-            <a:off x="451104" y="1405890"/>
-            <a:ext cx="792480" cy="754380"/>
+            <a:off x="1493520" y="1117854"/>
+            <a:ext cx="1219200" cy="754380"/>
           </a:xfrm>
           <a:noFill/>
           <a:ln>
@@ -2177,8 +1547,8 @@
         </p:nvSpPr>
         <p:spPr>
           <a:xfrm>
-            <a:off x="451104" y="3134106"/>
-            <a:ext cx="792480" cy="754380"/>
+            <a:off x="5492496" y="1117854"/>
+            <a:ext cx="1219200" cy="754380"/>
           </a:xfrm>
           <a:noFill/>
           <a:ln>
@@ -2243,8 +1613,8 @@
         </p:nvSpPr>
         <p:spPr>
           <a:xfrm>
-            <a:off x="451104" y="4862322"/>
-            <a:ext cx="792480" cy="754380"/>
+            <a:off x="9479280" y="1117854"/>
+            <a:ext cx="1219200" cy="754380"/>
           </a:xfrm>
           <a:noFill/>
           <a:ln>
@@ -3891,8 +3261,8 @@
 </file>
 
 <file path=ppt/slideLayouts/slideLayout6.xml><?xml version="1.0" encoding="utf-8"?>
-<p:sldLayout xmlns:a="http://schemas.openxmlformats.org/drawingml/2006/main" xmlns:r="http://schemas.openxmlformats.org/officeDocument/2006/relationships" xmlns:p="http://schemas.openxmlformats.org/presentationml/2006/main" type="cust" preserve="1">
-  <p:cSld name="kpi_big_number">
+<p:sldLayout xmlns:a="http://schemas.openxmlformats.org/drawingml/2006/main" xmlns:r="http://schemas.openxmlformats.org/officeDocument/2006/relationships" xmlns:p="http://schemas.openxmlformats.org/presentationml/2006/main" preserve="1" userDrawn="1" type="cust">
+  <p:cSld name="table_basic">
     <p:bg>
       <p:bgPr>
         <a:solidFill>
@@ -3917,116 +3287,7 @@
       </p:grpSpPr>
       <p:sp>
         <p:nvSpPr>
-          <p:cNvPr id="200" name="deco_metric_panel"/>
-          <p:cNvSpPr>
-            <a:spLocks noGrp="1"/>
-          </p:cNvSpPr>
-          <p:nvPr/>
-        </p:nvSpPr>
-        <p:spPr>
-          <a:xfrm>
-            <a:off x="707136" y="1062990"/>
-            <a:ext cx="8656320" cy="2537460"/>
-          </a:xfrm>
-          <a:prstGeom prst="rect">
-            <a:avLst/>
-          </a:prstGeom>
-          <a:solidFill>
-            <a:srgbClr val="1C3557"/>
-          </a:solidFill>
-          <a:ln>
-            <a:noFill/>
-          </a:ln>
-        </p:spPr>
-        <p:txBody>
-          <a:bodyPr/>
-          <a:lstStyle/>
-          <a:p/>
-        </p:txBody>
-      </p:sp>
-      <p:sp>
-        <p:nvSpPr>
-          <p:cNvPr id="201" name="deco_delta_badge"/>
-          <p:cNvSpPr>
-            <a:spLocks noGrp="1"/>
-          </p:cNvSpPr>
-          <p:nvPr/>
-        </p:nvSpPr>
-        <p:spPr>
-          <a:xfrm>
-            <a:off x="9534144" y="1062990"/>
-            <a:ext cx="2316480" cy="1028700"/>
-          </a:xfrm>
-          <a:prstGeom prst="rect">
-            <a:avLst/>
-          </a:prstGeom>
-          <a:solidFill>
-            <a:srgbClr val="E8763A"/>
-          </a:solidFill>
-          <a:ln>
-            <a:noFill/>
-          </a:ln>
-        </p:spPr>
-        <p:txBody>
-          <a:bodyPr/>
-          <a:lstStyle/>
-          <a:p/>
-        </p:txBody>
-      </p:sp>
-      <p:sp>
-        <p:nvSpPr>
-          <p:cNvPr id="202" name="deco_support_area"/>
-          <p:cNvSpPr>
-            <a:spLocks noGrp="1"/>
-          </p:cNvSpPr>
-          <p:nvPr/>
-        </p:nvSpPr>
-        <p:spPr>
-          <a:xfrm>
-            <a:off x="707136" y="3703320"/>
-            <a:ext cx="10777728" cy="2125980"/>
-          </a:xfrm>
-          <a:prstGeom prst="rect">
-            <a:avLst/>
-          </a:prstGeom>
-          <a:solidFill>
-            <a:srgbClr val="F2F4F7"/>
-          </a:solidFill>
-          <a:ln>
-            <a:noFill/>
-          </a:ln>
-        </p:spPr>
-        <p:txBody>
-          <a:bodyPr/>
-          <a:lstStyle/>
-          <a:p/>
-        </p:txBody>
-      </p:sp>
-      <p:sp>
-        <p:nvSpPr>
-          <p:cNvPr id="2" name="Title 1"/>
-          <p:cNvSpPr>
-            <a:spLocks noGrp="1"/>
-          </p:cNvSpPr>
-          <p:nvPr>
-            <p:ph type="title"/>
-          </p:nvPr>
-        </p:nvSpPr>
-        <p:spPr/>
-        <p:txBody>
-          <a:bodyPr/>
-          <a:lstStyle/>
-          <a:p>
-            <a:r>
-              <a:rPr lang="en-US"/>
-              <a:t>Click to edit Master title style</a:t>
-            </a:r>
-          </a:p>
-        </p:txBody>
-      </p:sp>
-      <p:sp>
-        <p:nvSpPr>
-          <p:cNvPr id="3" name="Date Placeholder 2"/>
+          <p:cNvPr id="4" name="Date Placeholder 3"/>
           <p:cNvSpPr>
             <a:spLocks noGrp="1"/>
           </p:cNvSpPr>
@@ -4049,7 +3310,7 @@
       </p:sp>
       <p:sp>
         <p:nvSpPr>
-          <p:cNvPr id="4" name="Footer Placeholder 3"/>
+          <p:cNvPr id="5" name="Footer Placeholder 4"/>
           <p:cNvSpPr>
             <a:spLocks noGrp="1"/>
           </p:cNvSpPr>
@@ -4068,7 +3329,7 @@
       </p:sp>
       <p:sp>
         <p:nvSpPr>
-          <p:cNvPr id="5" name="Slide Number Placeholder 4"/>
+          <p:cNvPr id="6" name="Slide Number Placeholder 5"/>
           <p:cNvSpPr>
             <a:spLocks noGrp="1"/>
           </p:cNvSpPr>
@@ -4091,7 +3352,40 @@
       </p:sp>
       <p:sp>
         <p:nvSpPr>
-          <p:cNvPr id="6" name="slot__metric_value">
+          <p:cNvPr id="7" name="タイトル 6">
+            <a:extLst>
+              <a:ext uri="{FF2B5EF4-FFF2-40B4-BE49-F238E27FC236}">
+                <a16:creationId xmlns:a16="http://schemas.microsoft.com/office/drawing/2014/main" id="{11DAA64B-18C1-17A1-691C-30AB57B5A327}"/>
+              </a:ext>
+            </a:extLst>
+          </p:cNvPr>
+          <p:cNvSpPr>
+            <a:spLocks noGrp="1"/>
+          </p:cNvSpPr>
+          <p:nvPr>
+            <p:ph type="title"/>
+          </p:nvPr>
+        </p:nvSpPr>
+        <p:spPr>
+          <a:xfrm>
+            <a:off x="231648" y="219456"/>
+            <a:ext cx="11728704" cy="644652"/>
+          </a:xfrm>
+        </p:spPr>
+        <p:txBody>
+          <a:bodyPr/>
+          <a:lstStyle/>
+          <a:p>
+            <a:r>
+              <a:rPr kumimoji="1" lang="ja-JP" altLang="en-US"/>
+              <a:t>マスター タイトルの書式設定</a:t>
+            </a:r>
+          </a:p>
+        </p:txBody>
+      </p:sp>
+      <p:sp>
+        <p:nvSpPr>
+          <p:cNvPr id="9" name="slot__table">
             <a:extLst>
               <a:ext uri="{FF2B5EF4-FFF2-40B4-BE49-F238E27FC236}">
                 <a16:creationId xmlns:a16="http://schemas.microsoft.com/office/drawing/2014/main" id="{9972CBED-8C1F-F962-DF1D-46CEC7DCCBC5}"/>
@@ -4102,216 +3396,13 @@
             <a:spLocks noGrp="1"/>
           </p:cNvSpPr>
           <p:nvPr>
-            <p:ph sz="quarter" idx="13" type="obj"/>
+            <p:ph sz="quarter" idx="13" type="tbl"/>
           </p:nvPr>
         </p:nvSpPr>
         <p:spPr>
           <a:xfrm>
-            <a:off x="975360" y="1371600"/>
-            <a:ext cx="8168640" cy="2057400"/>
-          </a:xfrm>
-        </p:spPr>
-        <p:txBody>
-          <a:bodyPr/>
-          <a:lstStyle>
-            <a:lvl1pPr>
-              <a:defRPr sz="5600" b="1">
-                <a:solidFill>
-                  <a:srgbClr val="FFFFFF"/>
-                </a:solidFill>
-              </a:defRPr>
-            </a:lvl1pPr>
-            <a:lvl2pPr>
-              <a:defRPr sz="1800">
-                <a:solidFill>
-                  <a:srgbClr val="E8F2FB"/>
-                </a:solidFill>
-              </a:defRPr>
-            </a:lvl2pPr>
-          </a:lstStyle>
-          <a:p>
-            <a:pPr lvl="0"/>
-            <a:r>
-              <a:rPr kumimoji="1" lang="ja-JP" altLang="en-US"/>
-              <a:t>マスター テキストの書式設定</a:t>
-            </a:r>
-          </a:p>
-          <a:p>
-            <a:pPr lvl="1"/>
-            <a:r>
-              <a:rPr kumimoji="1" lang="ja-JP" altLang="en-US"/>
-              <a:t>第 </a:t>
-            </a:r>
-            <a:r>
-              <a:rPr kumimoji="1" lang="en-US" altLang="ja-JP"/>
-              <a:t>2 </a:t>
-            </a:r>
-            <a:r>
-              <a:rPr kumimoji="1" lang="ja-JP" altLang="en-US"/>
-              <a:t>レベル</a:t>
-            </a:r>
-          </a:p>
-          <a:p>
-            <a:pPr lvl="2"/>
-            <a:r>
-              <a:rPr kumimoji="1" lang="ja-JP" altLang="en-US"/>
-              <a:t>第 </a:t>
-            </a:r>
-            <a:r>
-              <a:rPr kumimoji="1" lang="en-US" altLang="ja-JP"/>
-              <a:t>3 </a:t>
-            </a:r>
-            <a:r>
-              <a:rPr kumimoji="1" lang="ja-JP" altLang="en-US"/>
-              <a:t>レベル</a:t>
-            </a:r>
-          </a:p>
-          <a:p>
-            <a:pPr lvl="3"/>
-            <a:r>
-              <a:rPr kumimoji="1" lang="ja-JP" altLang="en-US"/>
-              <a:t>第 </a:t>
-            </a:r>
-            <a:r>
-              <a:rPr kumimoji="1" lang="en-US" altLang="ja-JP"/>
-              <a:t>4 </a:t>
-            </a:r>
-            <a:r>
-              <a:rPr kumimoji="1" lang="ja-JP" altLang="en-US"/>
-              <a:t>レベル</a:t>
-            </a:r>
-          </a:p>
-          <a:p>
-            <a:pPr lvl="4"/>
-            <a:r>
-              <a:rPr kumimoji="1" lang="ja-JP" altLang="en-US"/>
-              <a:t>第 </a:t>
-            </a:r>
-            <a:r>
-              <a:rPr kumimoji="1" lang="en-US" altLang="ja-JP"/>
-              <a:t>5 </a:t>
-            </a:r>
-            <a:r>
-              <a:rPr kumimoji="1" lang="ja-JP" altLang="en-US"/>
-              <a:t>レベル</a:t>
-            </a:r>
-          </a:p>
-        </p:txBody>
-      </p:sp>
-      <p:sp>
-        <p:nvSpPr>
-          <p:cNvPr id="7" name="slot__metric_delta">
-            <a:extLst>
-              <a:ext uri="{FF2B5EF4-FFF2-40B4-BE49-F238E27FC236}">
-                <a16:creationId xmlns:a16="http://schemas.microsoft.com/office/drawing/2014/main" id="{9972CBED-8C1F-F962-DF1D-46CEC7DCCBC5}"/>
-              </a:ext>
-            </a:extLst>
-          </p:cNvPr>
-          <p:cNvSpPr>
-            <a:spLocks noGrp="1"/>
-          </p:cNvSpPr>
-          <p:nvPr>
-            <p:ph sz="quarter" idx="14" type="obj"/>
-          </p:nvPr>
-        </p:nvSpPr>
-        <p:spPr>
-          <a:xfrm>
-            <a:off x="9656064" y="1289304"/>
-            <a:ext cx="2072640" cy="651510"/>
-          </a:xfrm>
-        </p:spPr>
-        <p:txBody>
-          <a:bodyPr/>
-          <a:lstStyle/>
-          <a:p>
-            <a:pPr lvl="0"/>
-            <a:r>
-              <a:rPr kumimoji="1" lang="ja-JP" altLang="en-US"/>
-              <a:t>マスター テキストの書式設定</a:t>
-            </a:r>
-          </a:p>
-          <a:p>
-            <a:pPr lvl="1"/>
-            <a:r>
-              <a:rPr kumimoji="1" lang="ja-JP" altLang="en-US"/>
-              <a:t>第 </a:t>
-            </a:r>
-            <a:r>
-              <a:rPr kumimoji="1" lang="en-US" altLang="ja-JP"/>
-              <a:t>2 </a:t>
-            </a:r>
-            <a:r>
-              <a:rPr kumimoji="1" lang="ja-JP" altLang="en-US"/>
-              <a:t>レベル</a:t>
-            </a:r>
-          </a:p>
-          <a:p>
-            <a:pPr lvl="2"/>
-            <a:r>
-              <a:rPr kumimoji="1" lang="ja-JP" altLang="en-US"/>
-              <a:t>第 </a:t>
-            </a:r>
-            <a:r>
-              <a:rPr kumimoji="1" lang="en-US" altLang="ja-JP"/>
-              <a:t>3 </a:t>
-            </a:r>
-            <a:r>
-              <a:rPr kumimoji="1" lang="ja-JP" altLang="en-US"/>
-              <a:t>レベル</a:t>
-            </a:r>
-          </a:p>
-          <a:p>
-            <a:pPr lvl="3"/>
-            <a:r>
-              <a:rPr kumimoji="1" lang="ja-JP" altLang="en-US"/>
-              <a:t>第 </a:t>
-            </a:r>
-            <a:r>
-              <a:rPr kumimoji="1" lang="en-US" altLang="ja-JP"/>
-              <a:t>4 </a:t>
-            </a:r>
-            <a:r>
-              <a:rPr kumimoji="1" lang="ja-JP" altLang="en-US"/>
-              <a:t>レベル</a:t>
-            </a:r>
-          </a:p>
-          <a:p>
-            <a:pPr lvl="4"/>
-            <a:r>
-              <a:rPr kumimoji="1" lang="ja-JP" altLang="en-US"/>
-              <a:t>第 </a:t>
-            </a:r>
-            <a:r>
-              <a:rPr kumimoji="1" lang="en-US" altLang="ja-JP"/>
-              <a:t>5 </a:t>
-            </a:r>
-            <a:r>
-              <a:rPr kumimoji="1" lang="ja-JP" altLang="en-US"/>
-              <a:t>レベル</a:t>
-            </a:r>
-          </a:p>
-        </p:txBody>
-      </p:sp>
-      <p:sp>
-        <p:nvSpPr>
-          <p:cNvPr id="8" name="slot__supporting_points">
-            <a:extLst>
-              <a:ext uri="{FF2B5EF4-FFF2-40B4-BE49-F238E27FC236}">
-                <a16:creationId xmlns:a16="http://schemas.microsoft.com/office/drawing/2014/main" id="{9972CBED-8C1F-F962-DF1D-46CEC7DCCBC5}"/>
-              </a:ext>
-            </a:extLst>
-          </p:cNvPr>
-          <p:cNvSpPr>
-            <a:spLocks noGrp="1"/>
-          </p:cNvSpPr>
-          <p:nvPr>
-            <p:ph sz="quarter" idx="15" type="obj"/>
-          </p:nvPr>
-        </p:nvSpPr>
-        <p:spPr>
-          <a:xfrm>
-            <a:off x="1036320" y="3874770"/>
-            <a:ext cx="10119360" cy="1783080"/>
+            <a:off x="426720" y="1405890"/>
+            <a:ext cx="11338560" cy="4286250"/>
           </a:xfrm>
         </p:spPr>
         <p:txBody>
@@ -4400,8 +3491,8 @@
 </file>
 
 <file path=ppt/slideLayouts/slideLayout7.xml><?xml version="1.0" encoding="utf-8"?>
-<p:sldLayout xmlns:a="http://schemas.openxmlformats.org/drawingml/2006/main" xmlns:r="http://schemas.openxmlformats.org/officeDocument/2006/relationships" xmlns:p="http://schemas.openxmlformats.org/presentationml/2006/main" type="cust" preserve="1">
-  <p:cSld name="timeline">
+<p:sldLayout xmlns:a="http://schemas.openxmlformats.org/drawingml/2006/main" xmlns:r="http://schemas.openxmlformats.org/officeDocument/2006/relationships" xmlns:p="http://schemas.openxmlformats.org/presentationml/2006/main" preserve="1" userDrawn="1" type="cust">
+  <p:cSld name="chart_basic">
     <p:bg>
       <p:bgPr>
         <a:solidFill>
@@ -4426,210 +3517,7 @@
       </p:grpSpPr>
       <p:sp>
         <p:nvSpPr>
-          <p:cNvPr id="200" name="deco_timeline_line"/>
-          <p:cNvSpPr>
-            <a:spLocks noGrp="1"/>
-          </p:cNvSpPr>
-          <p:nvPr/>
-        </p:nvSpPr>
-        <p:spPr>
-          <a:xfrm>
-            <a:off x="731520" y="1042416"/>
-            <a:ext cx="97536" cy="5225796"/>
-          </a:xfrm>
-          <a:prstGeom prst="rect">
-            <a:avLst/>
-          </a:prstGeom>
-          <a:solidFill>
-            <a:srgbClr val="2E6DA4"/>
-          </a:solidFill>
-          <a:ln>
-            <a:noFill/>
-          </a:ln>
-        </p:spPr>
-        <p:txBody>
-          <a:bodyPr/>
-          <a:lstStyle/>
-          <a:p/>
-        </p:txBody>
-      </p:sp>
-      <p:sp>
-        <p:nvSpPr>
-          <p:cNvPr id="201" name="deco_event_1_dot"/>
-          <p:cNvSpPr>
-            <a:spLocks noGrp="1"/>
-          </p:cNvSpPr>
-          <p:nvPr/>
-        </p:nvSpPr>
-        <p:spPr>
-          <a:xfrm>
-            <a:off x="633984" y="1419606"/>
-            <a:ext cx="292608" cy="205740"/>
-          </a:xfrm>
-          <a:prstGeom prst="ellipse">
-            <a:avLst/>
-          </a:prstGeom>
-          <a:solidFill>
-            <a:srgbClr val="1C3557"/>
-          </a:solidFill>
-          <a:ln>
-            <a:noFill/>
-          </a:ln>
-        </p:spPr>
-        <p:txBody>
-          <a:bodyPr/>
-          <a:lstStyle/>
-          <a:p/>
-        </p:txBody>
-      </p:sp>
-      <p:sp>
-        <p:nvSpPr>
-          <p:cNvPr id="202" name="deco_event_2_dot"/>
-          <p:cNvSpPr>
-            <a:spLocks noGrp="1"/>
-          </p:cNvSpPr>
-          <p:nvPr/>
-        </p:nvSpPr>
-        <p:spPr>
-          <a:xfrm>
-            <a:off x="633984" y="2269998"/>
-            <a:ext cx="292608" cy="205740"/>
-          </a:xfrm>
-          <a:prstGeom prst="ellipse">
-            <a:avLst/>
-          </a:prstGeom>
-          <a:solidFill>
-            <a:srgbClr val="1C3557"/>
-          </a:solidFill>
-          <a:ln>
-            <a:noFill/>
-          </a:ln>
-        </p:spPr>
-        <p:txBody>
-          <a:bodyPr/>
-          <a:lstStyle/>
-          <a:p/>
-        </p:txBody>
-      </p:sp>
-      <p:sp>
-        <p:nvSpPr>
-          <p:cNvPr id="203" name="deco_event_3_dot"/>
-          <p:cNvSpPr>
-            <a:spLocks noGrp="1"/>
-          </p:cNvSpPr>
-          <p:nvPr/>
-        </p:nvSpPr>
-        <p:spPr>
-          <a:xfrm>
-            <a:off x="633984" y="3120390"/>
-            <a:ext cx="292608" cy="205740"/>
-          </a:xfrm>
-          <a:prstGeom prst="ellipse">
-            <a:avLst/>
-          </a:prstGeom>
-          <a:solidFill>
-            <a:srgbClr val="1C3557"/>
-          </a:solidFill>
-          <a:ln>
-            <a:noFill/>
-          </a:ln>
-        </p:spPr>
-        <p:txBody>
-          <a:bodyPr/>
-          <a:lstStyle/>
-          <a:p/>
-        </p:txBody>
-      </p:sp>
-      <p:sp>
-        <p:nvSpPr>
-          <p:cNvPr id="204" name="deco_event_4_dot"/>
-          <p:cNvSpPr>
-            <a:spLocks noGrp="1"/>
-          </p:cNvSpPr>
-          <p:nvPr/>
-        </p:nvSpPr>
-        <p:spPr>
-          <a:xfrm>
-            <a:off x="633984" y="3970782"/>
-            <a:ext cx="292608" cy="205740"/>
-          </a:xfrm>
-          <a:prstGeom prst="ellipse">
-            <a:avLst/>
-          </a:prstGeom>
-          <a:solidFill>
-            <a:srgbClr val="1C3557"/>
-          </a:solidFill>
-          <a:ln>
-            <a:noFill/>
-          </a:ln>
-        </p:spPr>
-        <p:txBody>
-          <a:bodyPr/>
-          <a:lstStyle/>
-          <a:p/>
-        </p:txBody>
-      </p:sp>
-      <p:sp>
-        <p:nvSpPr>
-          <p:cNvPr id="205" name="deco_event_5_dot"/>
-          <p:cNvSpPr>
-            <a:spLocks noGrp="1"/>
-          </p:cNvSpPr>
-          <p:nvPr/>
-        </p:nvSpPr>
-        <p:spPr>
-          <a:xfrm>
-            <a:off x="633984" y="4821174"/>
-            <a:ext cx="292608" cy="205740"/>
-          </a:xfrm>
-          <a:prstGeom prst="ellipse">
-            <a:avLst/>
-          </a:prstGeom>
-          <a:solidFill>
-            <a:srgbClr val="1C3557"/>
-          </a:solidFill>
-          <a:ln>
-            <a:noFill/>
-          </a:ln>
-        </p:spPr>
-        <p:txBody>
-          <a:bodyPr/>
-          <a:lstStyle/>
-          <a:p/>
-        </p:txBody>
-      </p:sp>
-      <p:sp>
-        <p:nvSpPr>
-          <p:cNvPr id="206" name="deco_event_6_dot"/>
-          <p:cNvSpPr>
-            <a:spLocks noGrp="1"/>
-          </p:cNvSpPr>
-          <p:nvPr/>
-        </p:nvSpPr>
-        <p:spPr>
-          <a:xfrm>
-            <a:off x="633984" y="5671566"/>
-            <a:ext cx="292608" cy="205740"/>
-          </a:xfrm>
-          <a:prstGeom prst="ellipse">
-            <a:avLst/>
-          </a:prstGeom>
-          <a:solidFill>
-            <a:srgbClr val="1C3557"/>
-          </a:solidFill>
-          <a:ln>
-            <a:noFill/>
-          </a:ln>
-        </p:spPr>
-        <p:txBody>
-          <a:bodyPr/>
-          <a:lstStyle/>
-          <a:p/>
-        </p:txBody>
-      </p:sp>
-      <p:sp>
-        <p:nvSpPr>
-          <p:cNvPr id="2" name="Date Placeholder 1"/>
+          <p:cNvPr id="4" name="Date Placeholder 3"/>
           <p:cNvSpPr>
             <a:spLocks noGrp="1"/>
           </p:cNvSpPr>
@@ -4652,7 +3540,7 @@
       </p:sp>
       <p:sp>
         <p:nvSpPr>
-          <p:cNvPr id="3" name="Footer Placeholder 2"/>
+          <p:cNvPr id="5" name="Footer Placeholder 4"/>
           <p:cNvSpPr>
             <a:spLocks noGrp="1"/>
           </p:cNvSpPr>
@@ -4671,7 +3559,7 @@
       </p:sp>
       <p:sp>
         <p:nvSpPr>
-          <p:cNvPr id="4" name="Slide Number Placeholder 3"/>
+          <p:cNvPr id="6" name="Slide Number Placeholder 5"/>
           <p:cNvSpPr>
             <a:spLocks noGrp="1"/>
           </p:cNvSpPr>
@@ -4694,7 +3582,7 @@
       </p:sp>
       <p:sp>
         <p:nvSpPr>
-          <p:cNvPr id="5" name="タイトル 6">
+          <p:cNvPr id="7" name="タイトル 6">
             <a:extLst>
               <a:ext uri="{FF2B5EF4-FFF2-40B4-BE49-F238E27FC236}">
                 <a16:creationId xmlns:a16="http://schemas.microsoft.com/office/drawing/2014/main" id="{11DAA64B-18C1-17A1-691C-30AB57B5A327}"/>
@@ -4727,7 +3615,7 @@
       </p:sp>
       <p:sp>
         <p:nvSpPr>
-          <p:cNvPr id="6" name="slot__event_1_combined_text">
+          <p:cNvPr id="9" name="slot__chart">
             <a:extLst>
               <a:ext uri="{FF2B5EF4-FFF2-40B4-BE49-F238E27FC236}">
                 <a16:creationId xmlns:a16="http://schemas.microsoft.com/office/drawing/2014/main" id="{9972CBED-8C1F-F962-DF1D-46CEC7DCCBC5}"/>
@@ -4738,483 +3626,13 @@
             <a:spLocks noGrp="1"/>
           </p:cNvSpPr>
           <p:nvPr>
-            <p:ph sz="quarter" idx="13" type="obj"/>
+            <p:ph sz="quarter" idx="13" type="chart"/>
           </p:nvPr>
         </p:nvSpPr>
         <p:spPr>
           <a:xfrm>
-            <a:off x="1219200" y="1179576"/>
-            <a:ext cx="10607040" cy="699516"/>
-          </a:xfrm>
-        </p:spPr>
-        <p:txBody>
-          <a:bodyPr/>
-          <a:lstStyle/>
-          <a:p>
-            <a:pPr lvl="0"/>
-            <a:r>
-              <a:rPr kumimoji="1" lang="ja-JP" altLang="en-US"/>
-              <a:t>マスター テキストの書式設定</a:t>
-            </a:r>
-          </a:p>
-          <a:p>
-            <a:pPr lvl="1"/>
-            <a:r>
-              <a:rPr kumimoji="1" lang="ja-JP" altLang="en-US"/>
-              <a:t>第 </a:t>
-            </a:r>
-            <a:r>
-              <a:rPr kumimoji="1" lang="en-US" altLang="ja-JP"/>
-              <a:t>2 </a:t>
-            </a:r>
-            <a:r>
-              <a:rPr kumimoji="1" lang="ja-JP" altLang="en-US"/>
-              <a:t>レベル</a:t>
-            </a:r>
-          </a:p>
-          <a:p>
-            <a:pPr lvl="2"/>
-            <a:r>
-              <a:rPr kumimoji="1" lang="ja-JP" altLang="en-US"/>
-              <a:t>第 </a:t>
-            </a:r>
-            <a:r>
-              <a:rPr kumimoji="1" lang="en-US" altLang="ja-JP"/>
-              <a:t>3 </a:t>
-            </a:r>
-            <a:r>
-              <a:rPr kumimoji="1" lang="ja-JP" altLang="en-US"/>
-              <a:t>レベル</a:t>
-            </a:r>
-          </a:p>
-          <a:p>
-            <a:pPr lvl="3"/>
-            <a:r>
-              <a:rPr kumimoji="1" lang="ja-JP" altLang="en-US"/>
-              <a:t>第 </a:t>
-            </a:r>
-            <a:r>
-              <a:rPr kumimoji="1" lang="en-US" altLang="ja-JP"/>
-              <a:t>4 </a:t>
-            </a:r>
-            <a:r>
-              <a:rPr kumimoji="1" lang="ja-JP" altLang="en-US"/>
-              <a:t>レベル</a:t>
-            </a:r>
-          </a:p>
-          <a:p>
-            <a:pPr lvl="4"/>
-            <a:r>
-              <a:rPr kumimoji="1" lang="ja-JP" altLang="en-US"/>
-              <a:t>第 </a:t>
-            </a:r>
-            <a:r>
-              <a:rPr kumimoji="1" lang="en-US" altLang="ja-JP"/>
-              <a:t>5 </a:t>
-            </a:r>
-            <a:r>
-              <a:rPr kumimoji="1" lang="ja-JP" altLang="en-US"/>
-              <a:t>レベル</a:t>
-            </a:r>
-          </a:p>
-        </p:txBody>
-      </p:sp>
-      <p:sp>
-        <p:nvSpPr>
-          <p:cNvPr id="7" name="slot__event_2_combined_text">
-            <a:extLst>
-              <a:ext uri="{FF2B5EF4-FFF2-40B4-BE49-F238E27FC236}">
-                <a16:creationId xmlns:a16="http://schemas.microsoft.com/office/drawing/2014/main" id="{9972CBED-8C1F-F962-DF1D-46CEC7DCCBC5}"/>
-              </a:ext>
-            </a:extLst>
-          </p:cNvPr>
-          <p:cNvSpPr>
-            <a:spLocks noGrp="1"/>
-          </p:cNvSpPr>
-          <p:nvPr>
-            <p:ph sz="quarter" idx="14" type="obj"/>
-          </p:nvPr>
-        </p:nvSpPr>
-        <p:spPr>
-          <a:xfrm>
-            <a:off x="1219200" y="2029968"/>
-            <a:ext cx="10607040" cy="699516"/>
-          </a:xfrm>
-        </p:spPr>
-        <p:txBody>
-          <a:bodyPr/>
-          <a:lstStyle/>
-          <a:p>
-            <a:pPr lvl="0"/>
-            <a:r>
-              <a:rPr kumimoji="1" lang="ja-JP" altLang="en-US"/>
-              <a:t>マスター テキストの書式設定</a:t>
-            </a:r>
-          </a:p>
-          <a:p>
-            <a:pPr lvl="1"/>
-            <a:r>
-              <a:rPr kumimoji="1" lang="ja-JP" altLang="en-US"/>
-              <a:t>第 </a:t>
-            </a:r>
-            <a:r>
-              <a:rPr kumimoji="1" lang="en-US" altLang="ja-JP"/>
-              <a:t>2 </a:t>
-            </a:r>
-            <a:r>
-              <a:rPr kumimoji="1" lang="ja-JP" altLang="en-US"/>
-              <a:t>レベル</a:t>
-            </a:r>
-          </a:p>
-          <a:p>
-            <a:pPr lvl="2"/>
-            <a:r>
-              <a:rPr kumimoji="1" lang="ja-JP" altLang="en-US"/>
-              <a:t>第 </a:t>
-            </a:r>
-            <a:r>
-              <a:rPr kumimoji="1" lang="en-US" altLang="ja-JP"/>
-              <a:t>3 </a:t>
-            </a:r>
-            <a:r>
-              <a:rPr kumimoji="1" lang="ja-JP" altLang="en-US"/>
-              <a:t>レベル</a:t>
-            </a:r>
-          </a:p>
-          <a:p>
-            <a:pPr lvl="3"/>
-            <a:r>
-              <a:rPr kumimoji="1" lang="ja-JP" altLang="en-US"/>
-              <a:t>第 </a:t>
-            </a:r>
-            <a:r>
-              <a:rPr kumimoji="1" lang="en-US" altLang="ja-JP"/>
-              <a:t>4 </a:t>
-            </a:r>
-            <a:r>
-              <a:rPr kumimoji="1" lang="ja-JP" altLang="en-US"/>
-              <a:t>レベル</a:t>
-            </a:r>
-          </a:p>
-          <a:p>
-            <a:pPr lvl="4"/>
-            <a:r>
-              <a:rPr kumimoji="1" lang="ja-JP" altLang="en-US"/>
-              <a:t>第 </a:t>
-            </a:r>
-            <a:r>
-              <a:rPr kumimoji="1" lang="en-US" altLang="ja-JP"/>
-              <a:t>5 </a:t>
-            </a:r>
-            <a:r>
-              <a:rPr kumimoji="1" lang="ja-JP" altLang="en-US"/>
-              <a:t>レベル</a:t>
-            </a:r>
-          </a:p>
-        </p:txBody>
-      </p:sp>
-      <p:sp>
-        <p:nvSpPr>
-          <p:cNvPr id="8" name="slot__event_3_combined_text">
-            <a:extLst>
-              <a:ext uri="{FF2B5EF4-FFF2-40B4-BE49-F238E27FC236}">
-                <a16:creationId xmlns:a16="http://schemas.microsoft.com/office/drawing/2014/main" id="{9972CBED-8C1F-F962-DF1D-46CEC7DCCBC5}"/>
-              </a:ext>
-            </a:extLst>
-          </p:cNvPr>
-          <p:cNvSpPr>
-            <a:spLocks noGrp="1"/>
-          </p:cNvSpPr>
-          <p:nvPr>
-            <p:ph sz="quarter" idx="15" type="obj"/>
-          </p:nvPr>
-        </p:nvSpPr>
-        <p:spPr>
-          <a:xfrm>
-            <a:off x="1219200" y="2880360"/>
-            <a:ext cx="10607040" cy="699516"/>
-          </a:xfrm>
-        </p:spPr>
-        <p:txBody>
-          <a:bodyPr/>
-          <a:lstStyle/>
-          <a:p>
-            <a:pPr lvl="0"/>
-            <a:r>
-              <a:rPr kumimoji="1" lang="ja-JP" altLang="en-US"/>
-              <a:t>マスター テキストの書式設定</a:t>
-            </a:r>
-          </a:p>
-          <a:p>
-            <a:pPr lvl="1"/>
-            <a:r>
-              <a:rPr kumimoji="1" lang="ja-JP" altLang="en-US"/>
-              <a:t>第 </a:t>
-            </a:r>
-            <a:r>
-              <a:rPr kumimoji="1" lang="en-US" altLang="ja-JP"/>
-              <a:t>2 </a:t>
-            </a:r>
-            <a:r>
-              <a:rPr kumimoji="1" lang="ja-JP" altLang="en-US"/>
-              <a:t>レベル</a:t>
-            </a:r>
-          </a:p>
-          <a:p>
-            <a:pPr lvl="2"/>
-            <a:r>
-              <a:rPr kumimoji="1" lang="ja-JP" altLang="en-US"/>
-              <a:t>第 </a:t>
-            </a:r>
-            <a:r>
-              <a:rPr kumimoji="1" lang="en-US" altLang="ja-JP"/>
-              <a:t>3 </a:t>
-            </a:r>
-            <a:r>
-              <a:rPr kumimoji="1" lang="ja-JP" altLang="en-US"/>
-              <a:t>レベル</a:t>
-            </a:r>
-          </a:p>
-          <a:p>
-            <a:pPr lvl="3"/>
-            <a:r>
-              <a:rPr kumimoji="1" lang="ja-JP" altLang="en-US"/>
-              <a:t>第 </a:t>
-            </a:r>
-            <a:r>
-              <a:rPr kumimoji="1" lang="en-US" altLang="ja-JP"/>
-              <a:t>4 </a:t>
-            </a:r>
-            <a:r>
-              <a:rPr kumimoji="1" lang="ja-JP" altLang="en-US"/>
-              <a:t>レベル</a:t>
-            </a:r>
-          </a:p>
-          <a:p>
-            <a:pPr lvl="4"/>
-            <a:r>
-              <a:rPr kumimoji="1" lang="ja-JP" altLang="en-US"/>
-              <a:t>第 </a:t>
-            </a:r>
-            <a:r>
-              <a:rPr kumimoji="1" lang="en-US" altLang="ja-JP"/>
-              <a:t>5 </a:t>
-            </a:r>
-            <a:r>
-              <a:rPr kumimoji="1" lang="ja-JP" altLang="en-US"/>
-              <a:t>レベル</a:t>
-            </a:r>
-          </a:p>
-        </p:txBody>
-      </p:sp>
-      <p:sp>
-        <p:nvSpPr>
-          <p:cNvPr id="9" name="slot__event_4_combined_text">
-            <a:extLst>
-              <a:ext uri="{FF2B5EF4-FFF2-40B4-BE49-F238E27FC236}">
-                <a16:creationId xmlns:a16="http://schemas.microsoft.com/office/drawing/2014/main" id="{9972CBED-8C1F-F962-DF1D-46CEC7DCCBC5}"/>
-              </a:ext>
-            </a:extLst>
-          </p:cNvPr>
-          <p:cNvSpPr>
-            <a:spLocks noGrp="1"/>
-          </p:cNvSpPr>
-          <p:nvPr>
-            <p:ph sz="quarter" idx="16" type="obj"/>
-          </p:nvPr>
-        </p:nvSpPr>
-        <p:spPr>
-          <a:xfrm>
-            <a:off x="1219200" y="3730752"/>
-            <a:ext cx="10607040" cy="699516"/>
-          </a:xfrm>
-        </p:spPr>
-        <p:txBody>
-          <a:bodyPr/>
-          <a:lstStyle/>
-          <a:p>
-            <a:pPr lvl="0"/>
-            <a:r>
-              <a:rPr kumimoji="1" lang="ja-JP" altLang="en-US"/>
-              <a:t>マスター テキストの書式設定</a:t>
-            </a:r>
-          </a:p>
-          <a:p>
-            <a:pPr lvl="1"/>
-            <a:r>
-              <a:rPr kumimoji="1" lang="ja-JP" altLang="en-US"/>
-              <a:t>第 </a:t>
-            </a:r>
-            <a:r>
-              <a:rPr kumimoji="1" lang="en-US" altLang="ja-JP"/>
-              <a:t>2 </a:t>
-            </a:r>
-            <a:r>
-              <a:rPr kumimoji="1" lang="ja-JP" altLang="en-US"/>
-              <a:t>レベル</a:t>
-            </a:r>
-          </a:p>
-          <a:p>
-            <a:pPr lvl="2"/>
-            <a:r>
-              <a:rPr kumimoji="1" lang="ja-JP" altLang="en-US"/>
-              <a:t>第 </a:t>
-            </a:r>
-            <a:r>
-              <a:rPr kumimoji="1" lang="en-US" altLang="ja-JP"/>
-              <a:t>3 </a:t>
-            </a:r>
-            <a:r>
-              <a:rPr kumimoji="1" lang="ja-JP" altLang="en-US"/>
-              <a:t>レベル</a:t>
-            </a:r>
-          </a:p>
-          <a:p>
-            <a:pPr lvl="3"/>
-            <a:r>
-              <a:rPr kumimoji="1" lang="ja-JP" altLang="en-US"/>
-              <a:t>第 </a:t>
-            </a:r>
-            <a:r>
-              <a:rPr kumimoji="1" lang="en-US" altLang="ja-JP"/>
-              <a:t>4 </a:t>
-            </a:r>
-            <a:r>
-              <a:rPr kumimoji="1" lang="ja-JP" altLang="en-US"/>
-              <a:t>レベル</a:t>
-            </a:r>
-          </a:p>
-          <a:p>
-            <a:pPr lvl="4"/>
-            <a:r>
-              <a:rPr kumimoji="1" lang="ja-JP" altLang="en-US"/>
-              <a:t>第 </a:t>
-            </a:r>
-            <a:r>
-              <a:rPr kumimoji="1" lang="en-US" altLang="ja-JP"/>
-              <a:t>5 </a:t>
-            </a:r>
-            <a:r>
-              <a:rPr kumimoji="1" lang="ja-JP" altLang="en-US"/>
-              <a:t>レベル</a:t>
-            </a:r>
-          </a:p>
-        </p:txBody>
-      </p:sp>
-      <p:sp>
-        <p:nvSpPr>
-          <p:cNvPr id="10" name="slot__event_5_combined_text">
-            <a:extLst>
-              <a:ext uri="{FF2B5EF4-FFF2-40B4-BE49-F238E27FC236}">
-                <a16:creationId xmlns:a16="http://schemas.microsoft.com/office/drawing/2014/main" id="{9972CBED-8C1F-F962-DF1D-46CEC7DCCBC5}"/>
-              </a:ext>
-            </a:extLst>
-          </p:cNvPr>
-          <p:cNvSpPr>
-            <a:spLocks noGrp="1"/>
-          </p:cNvSpPr>
-          <p:nvPr>
-            <p:ph sz="quarter" idx="17" type="obj"/>
-          </p:nvPr>
-        </p:nvSpPr>
-        <p:spPr>
-          <a:xfrm>
-            <a:off x="1219200" y="4581144"/>
-            <a:ext cx="10607040" cy="699516"/>
-          </a:xfrm>
-        </p:spPr>
-        <p:txBody>
-          <a:bodyPr/>
-          <a:lstStyle/>
-          <a:p>
-            <a:pPr lvl="0"/>
-            <a:r>
-              <a:rPr kumimoji="1" lang="ja-JP" altLang="en-US"/>
-              <a:t>マスター テキストの書式設定</a:t>
-            </a:r>
-          </a:p>
-          <a:p>
-            <a:pPr lvl="1"/>
-            <a:r>
-              <a:rPr kumimoji="1" lang="ja-JP" altLang="en-US"/>
-              <a:t>第 </a:t>
-            </a:r>
-            <a:r>
-              <a:rPr kumimoji="1" lang="en-US" altLang="ja-JP"/>
-              <a:t>2 </a:t>
-            </a:r>
-            <a:r>
-              <a:rPr kumimoji="1" lang="ja-JP" altLang="en-US"/>
-              <a:t>レベル</a:t>
-            </a:r>
-          </a:p>
-          <a:p>
-            <a:pPr lvl="2"/>
-            <a:r>
-              <a:rPr kumimoji="1" lang="ja-JP" altLang="en-US"/>
-              <a:t>第 </a:t>
-            </a:r>
-            <a:r>
-              <a:rPr kumimoji="1" lang="en-US" altLang="ja-JP"/>
-              <a:t>3 </a:t>
-            </a:r>
-            <a:r>
-              <a:rPr kumimoji="1" lang="ja-JP" altLang="en-US"/>
-              <a:t>レベル</a:t>
-            </a:r>
-          </a:p>
-          <a:p>
-            <a:pPr lvl="3"/>
-            <a:r>
-              <a:rPr kumimoji="1" lang="ja-JP" altLang="en-US"/>
-              <a:t>第 </a:t>
-            </a:r>
-            <a:r>
-              <a:rPr kumimoji="1" lang="en-US" altLang="ja-JP"/>
-              <a:t>4 </a:t>
-            </a:r>
-            <a:r>
-              <a:rPr kumimoji="1" lang="ja-JP" altLang="en-US"/>
-              <a:t>レベル</a:t>
-            </a:r>
-          </a:p>
-          <a:p>
-            <a:pPr lvl="4"/>
-            <a:r>
-              <a:rPr kumimoji="1" lang="ja-JP" altLang="en-US"/>
-              <a:t>第 </a:t>
-            </a:r>
-            <a:r>
-              <a:rPr kumimoji="1" lang="en-US" altLang="ja-JP"/>
-              <a:t>5 </a:t>
-            </a:r>
-            <a:r>
-              <a:rPr kumimoji="1" lang="ja-JP" altLang="en-US"/>
-              <a:t>レベル</a:t>
-            </a:r>
-          </a:p>
-        </p:txBody>
-      </p:sp>
-      <p:sp>
-        <p:nvSpPr>
-          <p:cNvPr id="11" name="slot__event_6_combined_text">
-            <a:extLst>
-              <a:ext uri="{FF2B5EF4-FFF2-40B4-BE49-F238E27FC236}">
-                <a16:creationId xmlns:a16="http://schemas.microsoft.com/office/drawing/2014/main" id="{9972CBED-8C1F-F962-DF1D-46CEC7DCCBC5}"/>
-              </a:ext>
-            </a:extLst>
-          </p:cNvPr>
-          <p:cNvSpPr>
-            <a:spLocks noGrp="1"/>
-          </p:cNvSpPr>
-          <p:nvPr>
-            <p:ph sz="quarter" idx="18" type="obj"/>
-          </p:nvPr>
-        </p:nvSpPr>
-        <p:spPr>
-          <a:xfrm>
-            <a:off x="1219200" y="5431536"/>
-            <a:ext cx="10607040" cy="699516"/>
+            <a:off x="426720" y="1405890"/>
+            <a:ext cx="11338560" cy="4286250"/>
           </a:xfrm>
         </p:spPr>
         <p:txBody>
@@ -6554,26 +4972,52 @@
         <p:nvPr/>
       </p:nvGrpSpPr>
       <p:grpSpPr/>
-      <p:sp>
-        <p:nvSpPr>
-          <p:cNvPr id="2" name="Subtitle 1"/>
-          <p:cNvSpPr>
-            <a:spLocks noGrp="1"/>
-          </p:cNvSpPr>
-          <p:nvPr>
-            <p:ph type="subTitle" idx="1"/>
-          </p:nvPr>
-        </p:nvSpPr>
-        <p:spPr/>
-        <p:txBody>
-          <a:bodyPr/>
-          <a:lstStyle/>
-          <a:p/>
-        </p:txBody>
-      </p:sp>
-      <p:sp>
-        <p:nvSpPr>
-          <p:cNvPr id="3" name="Title 2"/>
+      <p:pic>
+        <p:nvPicPr>
+          <p:cNvPr id="2" name="Picture Placeholder 1" descr="image.png"/>
+          <p:cNvPicPr>
+            <a:picLocks noGrp="1" noChangeAspect="1"/>
+          </p:cNvPicPr>
+          <p:nvPr>
+            <p:ph type="pic" idx="1"/>
+          </p:nvPr>
+        </p:nvPicPr>
+        <p:blipFill>
+          <a:blip r:embed="rId2"/>
+          <a:srcRect t="18016" b="18016"/>
+          <a:stretch>
+            <a:fillRect/>
+          </a:stretch>
+        </p:blipFill>
+        <p:spPr/>
+      </p:pic>
+      <p:sp>
+        <p:nvSpPr>
+          <p:cNvPr id="3" name="Text Placeholder 2"/>
+          <p:cNvSpPr>
+            <a:spLocks noGrp="1"/>
+          </p:cNvSpPr>
+          <p:nvPr>
+            <p:ph type="body" idx="2" sz="half"/>
+          </p:nvPr>
+        </p:nvSpPr>
+        <p:spPr/>
+        <p:txBody>
+          <a:bodyPr/>
+          <a:lstStyle/>
+          <a:p>
+            <a:pPr>
+              <a:buNone/>
+            </a:pPr>
+            <a:r>
+              <a:t>Built-in picture placeholder rendering sample</a:t>
+            </a:r>
+          </a:p>
+        </p:txBody>
+      </p:sp>
+      <p:sp>
+        <p:nvSpPr>
+          <p:cNvPr id="4" name="Title 3"/>
           <p:cNvSpPr>
             <a:spLocks noGrp="1"/>
           </p:cNvSpPr>
@@ -6590,7 +5034,7 @@
               <a:buNone/>
             </a:pPr>
             <a:r>
-              <a:t>Thanks</a:t>
+              <a:t>Icon</a:t>
             </a:r>
           </a:p>
         </p:txBody>
@@ -6632,7 +5076,7 @@
               <a:buNone/>
             </a:pPr>
             <a:r>
-              <a:t>KPI</a:t>
+              <a:t>Appendix</a:t>
             </a:r>
           </a:p>
         </p:txBody>
@@ -6656,15 +5100,17 @@
               <a:buNone/>
             </a:pPr>
             <a:r>
-              <a:t>42</a:t>
-            </a:r>
-          </a:p>
-          <a:p>
-            <a:pPr>
-              <a:buNone/>
-            </a:pPr>
-            <a:r>
-              <a:t>Customers</a:t>
+              <a:t>Supporting notes</a:t>
+            </a:r>
+          </a:p>
+          <a:p>
+            <a:r>
+              <a:t>Ref</a:t>
+            </a:r>
+          </a:p>
+          <a:p>
+            <a:r>
+              <a:t>Checklist</a:t>
             </a:r>
           </a:p>
         </p:txBody>
@@ -6684,299 +5130,6 @@
           <a:bodyPr/>
           <a:lstStyle/>
           <a:p>
-            <a:pPr>
-              <a:buNone/>
-            </a:pPr>
-            <a:r>
-              <a:t>+18%</a:t>
-            </a:r>
-          </a:p>
-        </p:txBody>
-      </p:sp>
-      <p:sp>
-        <p:nvSpPr>
-          <p:cNvPr id="5" name="Content Placeholder 4"/>
-          <p:cNvSpPr>
-            <a:spLocks noGrp="1"/>
-          </p:cNvSpPr>
-          <p:nvPr>
-            <p:ph idx="15" sz="quarter"/>
-          </p:nvPr>
-        </p:nvSpPr>
-        <p:spPr/>
-        <p:txBody>
-          <a:bodyPr/>
-          <a:lstStyle/>
-          <a:p>
-            <a:r>
-              <a:t>NPS up 6 pt</a:t>
-            </a:r>
-          </a:p>
-          <a:p>
-            <a:r>
-              <a:t>Churn down 2 pt</a:t>
-            </a:r>
-          </a:p>
-          <a:p>
-            <a:r>
-              <a:t>API usage doubled</a:t>
-            </a:r>
-          </a:p>
-        </p:txBody>
-      </p:sp>
-    </p:spTree>
-  </p:cSld>
-  <p:clrMapOvr>
-    <a:masterClrMapping/>
-  </p:clrMapOvr>
-</p:sld>
-</file>
-
-<file path=ppt/slides/slide12.xml><?xml version="1.0" encoding="utf-8"?>
-<p:sld xmlns:a="http://schemas.openxmlformats.org/drawingml/2006/main" xmlns:p="http://schemas.openxmlformats.org/presentationml/2006/main" xmlns:r="http://schemas.openxmlformats.org/officeDocument/2006/relationships">
-  <p:cSld>
-    <p:spTree>
-      <p:nvGrpSpPr>
-        <p:cNvPr id="1" name=""/>
-        <p:cNvGrpSpPr/>
-        <p:nvPr/>
-      </p:nvGrpSpPr>
-      <p:grpSpPr/>
-      <p:sp>
-        <p:nvSpPr>
-          <p:cNvPr id="2" name="Title 1"/>
-          <p:cNvSpPr>
-            <a:spLocks noGrp="1"/>
-          </p:cNvSpPr>
-          <p:nvPr>
-            <p:ph type="title"/>
-          </p:nvPr>
-        </p:nvSpPr>
-        <p:spPr/>
-        <p:txBody>
-          <a:bodyPr/>
-          <a:lstStyle/>
-          <a:p>
-            <a:pPr>
-              <a:buNone/>
-            </a:pPr>
-            <a:r>
-              <a:t>Chart</a:t>
-            </a:r>
-          </a:p>
-        </p:txBody>
-      </p:sp>
-      <p:sp>
-        <p:nvSpPr>
-          <p:cNvPr id="3" name="Content Placeholder 2"/>
-          <p:cNvSpPr>
-            <a:spLocks noGrp="1"/>
-          </p:cNvSpPr>
-          <p:nvPr>
-            <p:ph idx="13" sz="quarter"/>
-          </p:nvPr>
-        </p:nvSpPr>
-        <p:spPr/>
-        <p:txBody>
-          <a:bodyPr/>
-          <a:lstStyle/>
-          <a:p/>
-        </p:txBody>
-      </p:sp>
-      <p:graphicFrame>
-        <p:nvGraphicFramePr>
-          <p:cNvPr id="4" name="Chart 3"/>
-          <p:cNvGraphicFramePr>
-            <a:graphicFrameLocks noGrp="1"/>
-          </p:cNvGraphicFramePr>
-          <p:nvPr/>
-        </p:nvGraphicFramePr>
-        <p:xfrm>
-          <a:off x="226422" y="1114425"/>
-          <a:ext cx="11730445" cy="4998992"/>
-        </p:xfrm>
-        <a:graphic>
-          <a:graphicData uri="http://schemas.openxmlformats.org/drawingml/2006/chart">
-            <c:chart xmlns:c="http://schemas.openxmlformats.org/drawingml/2006/chart" r:id="rId2"/>
-          </a:graphicData>
-        </a:graphic>
-      </p:graphicFrame>
-    </p:spTree>
-  </p:cSld>
-  <p:clrMapOvr>
-    <a:masterClrMapping/>
-  </p:clrMapOvr>
-</p:sld>
-</file>
-
-<file path=ppt/slides/slide13.xml><?xml version="1.0" encoding="utf-8"?>
-<p:sld xmlns:a="http://schemas.openxmlformats.org/drawingml/2006/main" xmlns:p="http://schemas.openxmlformats.org/presentationml/2006/main" xmlns:r="http://schemas.openxmlformats.org/officeDocument/2006/relationships">
-  <p:cSld>
-    <p:spTree>
-      <p:nvGrpSpPr>
-        <p:cNvPr id="1" name=""/>
-        <p:cNvGrpSpPr/>
-        <p:nvPr/>
-      </p:nvGrpSpPr>
-      <p:grpSpPr/>
-      <p:pic>
-        <p:nvPicPr>
-          <p:cNvPr id="2" name="Picture Placeholder 1" descr="image.png"/>
-          <p:cNvPicPr>
-            <a:picLocks noGrp="1" noChangeAspect="1"/>
-          </p:cNvPicPr>
-          <p:nvPr>
-            <p:ph type="pic" idx="1"/>
-          </p:nvPr>
-        </p:nvPicPr>
-        <p:blipFill>
-          <a:blip r:embed="rId2"/>
-          <a:srcRect t="18016" b="18016"/>
-          <a:stretch>
-            <a:fillRect/>
-          </a:stretch>
-        </p:blipFill>
-        <p:spPr/>
-      </p:pic>
-      <p:sp>
-        <p:nvSpPr>
-          <p:cNvPr id="3" name="Text Placeholder 2"/>
-          <p:cNvSpPr>
-            <a:spLocks noGrp="1"/>
-          </p:cNvSpPr>
-          <p:nvPr>
-            <p:ph type="body" idx="2" sz="half"/>
-          </p:nvPr>
-        </p:nvSpPr>
-        <p:spPr/>
-        <p:txBody>
-          <a:bodyPr/>
-          <a:lstStyle/>
-          <a:p>
-            <a:pPr>
-              <a:buNone/>
-            </a:pPr>
-            <a:r>
-              <a:t>Built-in picture placeholder rendering sample</a:t>
-            </a:r>
-          </a:p>
-        </p:txBody>
-      </p:sp>
-      <p:sp>
-        <p:nvSpPr>
-          <p:cNvPr id="4" name="Title 3"/>
-          <p:cNvSpPr>
-            <a:spLocks noGrp="1"/>
-          </p:cNvSpPr>
-          <p:nvPr>
-            <p:ph type="title"/>
-          </p:nvPr>
-        </p:nvSpPr>
-        <p:spPr/>
-        <p:txBody>
-          <a:bodyPr/>
-          <a:lstStyle/>
-          <a:p>
-            <a:pPr>
-              <a:buNone/>
-            </a:pPr>
-            <a:r>
-              <a:t>Icon</a:t>
-            </a:r>
-          </a:p>
-        </p:txBody>
-      </p:sp>
-    </p:spTree>
-  </p:cSld>
-  <p:clrMapOvr>
-    <a:masterClrMapping/>
-  </p:clrMapOvr>
-</p:sld>
-</file>
-
-<file path=ppt/slides/slide14.xml><?xml version="1.0" encoding="utf-8"?>
-<p:sld xmlns:a="http://schemas.openxmlformats.org/drawingml/2006/main" xmlns:p="http://schemas.openxmlformats.org/presentationml/2006/main" xmlns:r="http://schemas.openxmlformats.org/officeDocument/2006/relationships">
-  <p:cSld>
-    <p:spTree>
-      <p:nvGrpSpPr>
-        <p:cNvPr id="1" name=""/>
-        <p:cNvGrpSpPr/>
-        <p:nvPr/>
-      </p:nvGrpSpPr>
-      <p:grpSpPr/>
-      <p:sp>
-        <p:nvSpPr>
-          <p:cNvPr id="2" name="Title 1"/>
-          <p:cNvSpPr>
-            <a:spLocks noGrp="1"/>
-          </p:cNvSpPr>
-          <p:nvPr>
-            <p:ph type="title"/>
-          </p:nvPr>
-        </p:nvSpPr>
-        <p:spPr/>
-        <p:txBody>
-          <a:bodyPr/>
-          <a:lstStyle/>
-          <a:p>
-            <a:pPr>
-              <a:buNone/>
-            </a:pPr>
-            <a:r>
-              <a:t>Appendix</a:t>
-            </a:r>
-          </a:p>
-        </p:txBody>
-      </p:sp>
-      <p:sp>
-        <p:nvSpPr>
-          <p:cNvPr id="3" name="Content Placeholder 2"/>
-          <p:cNvSpPr>
-            <a:spLocks noGrp="1"/>
-          </p:cNvSpPr>
-          <p:nvPr>
-            <p:ph idx="13" sz="quarter"/>
-          </p:nvPr>
-        </p:nvSpPr>
-        <p:spPr/>
-        <p:txBody>
-          <a:bodyPr/>
-          <a:lstStyle/>
-          <a:p>
-            <a:pPr>
-              <a:buNone/>
-            </a:pPr>
-            <a:r>
-              <a:t>Supporting notes</a:t>
-            </a:r>
-          </a:p>
-          <a:p>
-            <a:r>
-              <a:t>Ref</a:t>
-            </a:r>
-          </a:p>
-          <a:p>
-            <a:r>
-              <a:t>Checklist</a:t>
-            </a:r>
-          </a:p>
-        </p:txBody>
-      </p:sp>
-      <p:sp>
-        <p:nvSpPr>
-          <p:cNvPr id="4" name="Content Placeholder 3"/>
-          <p:cNvSpPr>
-            <a:spLocks noGrp="1"/>
-          </p:cNvSpPr>
-          <p:nvPr>
-            <p:ph idx="14" sz="quarter"/>
-          </p:nvPr>
-        </p:nvSpPr>
-        <p:spPr/>
-        <p:txBody>
-          <a:bodyPr/>
-          <a:lstStyle/>
-          <a:p>
             <a:r>
               <a:t>Source A</a:t>
             </a:r>
@@ -6987,178 +5140,6 @@
             </a:r>
           </a:p>
         </p:txBody>
-      </p:sp>
-    </p:spTree>
-  </p:cSld>
-  <p:clrMapOvr>
-    <a:masterClrMapping/>
-  </p:clrMapOvr>
-</p:sld>
-</file>
-
-<file path=ppt/slides/slide15.xml><?xml version="1.0" encoding="utf-8"?>
-<p:sld xmlns:a="http://schemas.openxmlformats.org/drawingml/2006/main" xmlns:p="http://schemas.openxmlformats.org/presentationml/2006/main" xmlns:r="http://schemas.openxmlformats.org/officeDocument/2006/relationships">
-  <p:cSld>
-    <p:spTree>
-      <p:nvGrpSpPr>
-        <p:cNvPr id="1" name=""/>
-        <p:cNvGrpSpPr/>
-        <p:nvPr/>
-      </p:nvGrpSpPr>
-      <p:grpSpPr/>
-      <p:sp>
-        <p:nvSpPr>
-          <p:cNvPr id="2" name="Text Placeholder 1"/>
-          <p:cNvSpPr>
-            <a:spLocks noGrp="1"/>
-          </p:cNvSpPr>
-          <p:nvPr>
-            <p:ph type="body" idx="1"/>
-          </p:nvPr>
-        </p:nvSpPr>
-        <p:spPr/>
-        <p:txBody>
-          <a:bodyPr/>
-          <a:lstStyle/>
-          <a:p>
-            <a:pPr>
-              <a:buNone/>
-            </a:pPr>
-            <a:r>
-              <a:t>Legacy API</a:t>
-            </a:r>
-          </a:p>
-        </p:txBody>
-      </p:sp>
-      <p:sp>
-        <p:nvSpPr>
-          <p:cNvPr id="3" name="Text Placeholder 2"/>
-          <p:cNvSpPr>
-            <a:spLocks noGrp="1"/>
-          </p:cNvSpPr>
-          <p:nvPr>
-            <p:ph type="body" idx="3" sz="quarter"/>
-          </p:nvPr>
-        </p:nvSpPr>
-        <p:spPr/>
-        <p:txBody>
-          <a:bodyPr/>
-          <a:lstStyle/>
-          <a:p>
-            <a:pPr>
-              <a:buNone/>
-            </a:pPr>
-            <a:r>
-              <a:t>2027-06-30</a:t>
-            </a:r>
-          </a:p>
-        </p:txBody>
-      </p:sp>
-      <p:sp>
-        <p:nvSpPr>
-          <p:cNvPr id="4" name="Title 3"/>
-          <p:cNvSpPr>
-            <a:spLocks noGrp="1"/>
-          </p:cNvSpPr>
-          <p:nvPr>
-            <p:ph type="title"/>
-          </p:nvPr>
-        </p:nvSpPr>
-        <p:spPr/>
-        <p:txBody>
-          <a:bodyPr/>
-          <a:lstStyle/>
-          <a:p>
-            <a:pPr>
-              <a:buNone/>
-            </a:pPr>
-            <a:r>
-              <a:t>EOL</a:t>
-            </a:r>
-          </a:p>
-        </p:txBody>
-      </p:sp>
-      <p:sp>
-        <p:nvSpPr>
-          <p:cNvPr id="5" name="Content Placeholder 4"/>
-          <p:cNvSpPr>
-            <a:spLocks noGrp="1"/>
-          </p:cNvSpPr>
-          <p:nvPr>
-            <p:ph idx="13" sz="quarter"/>
-          </p:nvPr>
-        </p:nvSpPr>
-        <p:spPr/>
-        <p:txBody>
-          <a:bodyPr/>
-          <a:lstStyle/>
-          <a:p>
-            <a:pPr>
-              <a:buNone/>
-            </a:pPr>
-            <a:r>
-              <a:t>2026-12-31</a:t>
-            </a:r>
-          </a:p>
-        </p:txBody>
-      </p:sp>
-      <p:sp>
-        <p:nvSpPr>
-          <p:cNvPr id="6" name="Content Placeholder 5"/>
-          <p:cNvSpPr>
-            <a:spLocks noGrp="1"/>
-          </p:cNvSpPr>
-          <p:nvPr>
-            <p:ph idx="14" sz="quarter"/>
-          </p:nvPr>
-        </p:nvSpPr>
-        <p:spPr/>
-        <p:txBody>
-          <a:bodyPr/>
-          <a:lstStyle/>
-          <a:p>
-            <a:pPr>
-              <a:buNone/>
-            </a:pPr>
-            <a:r>
-              <a:t>New Platform API</a:t>
-            </a:r>
-          </a:p>
-          <a:p>
-            <a:r>
-              <a:t>Migrate</a:t>
-            </a:r>
-          </a:p>
-          <a:p>
-            <a:r>
-              <a:t>Notify customers</a:t>
-            </a:r>
-          </a:p>
-        </p:txBody>
-      </p:sp>
-      <p:sp>
-        <p:nvSpPr>
-          <p:cNvPr id="7" name="Picture Placeholder 6"/>
-          <p:cNvSpPr>
-            <a:spLocks noGrp="1"/>
-          </p:cNvSpPr>
-          <p:nvPr>
-            <p:ph type="pic" idx="15"/>
-          </p:nvPr>
-        </p:nvSpPr>
-        <p:spPr/>
-      </p:sp>
-      <p:sp>
-        <p:nvSpPr>
-          <p:cNvPr id="8" name="Picture Placeholder 7"/>
-          <p:cNvSpPr>
-            <a:spLocks noGrp="1"/>
-          </p:cNvSpPr>
-          <p:nvPr>
-            <p:ph type="pic" idx="16"/>
-          </p:nvPr>
-        </p:nvSpPr>
-        <p:spPr/>
       </p:sp>
     </p:spTree>
   </p:cSld>
@@ -7399,34 +5380,19 @@
           </a:p>
         </p:txBody>
       </p:sp>
-      <p:sp>
-        <p:nvSpPr>
-          <p:cNvPr id="3" name="Content Placeholder 2"/>
-          <p:cNvSpPr>
-            <a:spLocks noGrp="1"/>
-          </p:cNvSpPr>
-          <p:nvPr>
-            <p:ph idx="13" sz="quarter"/>
-          </p:nvPr>
-        </p:nvSpPr>
-        <p:spPr/>
-        <p:txBody>
-          <a:bodyPr/>
-          <a:lstStyle/>
-          <a:p/>
-        </p:txBody>
-      </p:sp>
       <p:graphicFrame>
         <p:nvGraphicFramePr>
-          <p:cNvPr id="4" name="Table 3"/>
+          <p:cNvPr id="3" name="Table Placeholder 2"/>
           <p:cNvGraphicFramePr>
             <a:graphicFrameLocks noGrp="1"/>
           </p:cNvGraphicFramePr>
-          <p:nvPr/>
+          <p:nvPr>
+            <p:ph type="tbl" idx="13" sz="quarter"/>
+          </p:nvPr>
         </p:nvGraphicFramePr>
         <p:xfrm>
-          <a:off x="226422" y="1114425"/>
-          <a:ext cx="11730445" cy="4998992"/>
+          <a:off x="426720" y="1405890"/>
+          <a:ext cx="11338560" cy="741680"/>
         </p:xfrm>
         <a:graphic>
           <a:graphicData uri="http://schemas.openxmlformats.org/drawingml/2006/table">
@@ -7435,10 +5401,10 @@
                 <a:tableStyleId>{5C22544A-7EE6-4342-B048-85BDC9FD1C3A}</a:tableStyleId>
               </a:tblPr>
               <a:tblGrid>
-                <a:gridCol w="5865222"/>
-                <a:gridCol w="5865223"/>
+                <a:gridCol w="5669280"/>
+                <a:gridCol w="5669280"/>
               </a:tblGrid>
-              <a:tr h="2499496">
+              <a:tr h="370840">
                 <a:tc>
                   <a:txBody>
                     <a:bodyPr/>
@@ -7464,7 +5430,7 @@
                   <a:tcPr/>
                 </a:tc>
               </a:tr>
-              <a:tr h="2499496">
+              <a:tr h="370840">
                 <a:tc>
                   <a:txBody>
                     <a:bodyPr/>
@@ -7820,7 +5786,7 @@
         </p:nvPicPr>
         <p:blipFill>
           <a:blip r:embed="rId2"/>
-          <a:srcRect t="2404" b="2404"/>
+          <a:srcRect t="19062" b="19062"/>
           <a:stretch>
             <a:fillRect/>
           </a:stretch>
@@ -7839,7 +5805,7 @@
         </p:nvPicPr>
         <p:blipFill>
           <a:blip r:embed="rId2"/>
-          <a:srcRect t="2404" b="2404"/>
+          <a:srcRect t="19062" b="19062"/>
           <a:stretch>
             <a:fillRect/>
           </a:stretch>
@@ -7858,7 +5824,7 @@
         </p:nvPicPr>
         <p:blipFill>
           <a:blip r:embed="rId2"/>
-          <a:srcRect t="2404" b="2404"/>
+          <a:srcRect t="19062" b="19062"/>
           <a:stretch>
             <a:fillRect/>
           </a:stretch>
@@ -7885,7 +5851,24 @@
       <p:grpSpPr/>
       <p:sp>
         <p:nvSpPr>
-          <p:cNvPr id="2" name="Title 1"/>
+          <p:cNvPr id="2" name="Subtitle 1"/>
+          <p:cNvSpPr>
+            <a:spLocks noGrp="1"/>
+          </p:cNvSpPr>
+          <p:nvPr>
+            <p:ph type="subTitle" idx="1"/>
+          </p:nvPr>
+        </p:nvSpPr>
+        <p:spPr/>
+        <p:txBody>
+          <a:bodyPr/>
+          <a:lstStyle/>
+          <a:p/>
+        </p:txBody>
+      </p:sp>
+      <p:sp>
+        <p:nvSpPr>
+          <p:cNvPr id="3" name="Title 2"/>
           <p:cNvSpPr>
             <a:spLocks noGrp="1"/>
           </p:cNvSpPr>
@@ -7902,164 +5885,11 @@
               <a:buNone/>
             </a:pPr>
             <a:r>
-              <a:t>Cards H</a:t>
-            </a:r>
-          </a:p>
-        </p:txBody>
-      </p:sp>
-      <p:sp>
-        <p:nvSpPr>
-          <p:cNvPr id="3" name="Content Placeholder 2"/>
-          <p:cNvSpPr>
-            <a:spLocks noGrp="1"/>
-          </p:cNvSpPr>
-          <p:nvPr>
-            <p:ph idx="13" sz="quarter"/>
-          </p:nvPr>
-        </p:nvSpPr>
-        <p:spPr/>
-        <p:txBody>
-          <a:bodyPr/>
-          <a:lstStyle/>
-          <a:p>
-            <a:pPr>
-              <a:buNone/>
-            </a:pPr>
-            <a:r>
-              <a:t>A</a:t>
-            </a:r>
-          </a:p>
-          <a:p>
-            <a:pPr lvl="1">
-              <a:buNone/>
-            </a:pPr>
-            <a:r>
-              <a:t>AA</a:t>
-            </a:r>
-          </a:p>
-        </p:txBody>
-      </p:sp>
-      <p:sp>
-        <p:nvSpPr>
-          <p:cNvPr id="4" name="Content Placeholder 3"/>
-          <p:cNvSpPr>
-            <a:spLocks noGrp="1"/>
-          </p:cNvSpPr>
-          <p:nvPr>
-            <p:ph idx="14" sz="quarter"/>
-          </p:nvPr>
-        </p:nvSpPr>
-        <p:spPr/>
-        <p:txBody>
-          <a:bodyPr/>
-          <a:lstStyle/>
-          <a:p>
-            <a:pPr>
-              <a:buNone/>
-            </a:pPr>
-            <a:r>
-              <a:t>B</a:t>
-            </a:r>
-          </a:p>
-          <a:p>
-            <a:pPr lvl="1">
-              <a:buNone/>
-            </a:pPr>
-            <a:r>
-              <a:t>BB</a:t>
-            </a:r>
-          </a:p>
-        </p:txBody>
-      </p:sp>
-      <p:sp>
-        <p:nvSpPr>
-          <p:cNvPr id="5" name="Content Placeholder 4"/>
-          <p:cNvSpPr>
-            <a:spLocks noGrp="1"/>
-          </p:cNvSpPr>
-          <p:nvPr>
-            <p:ph idx="15" sz="quarter"/>
-          </p:nvPr>
-        </p:nvSpPr>
-        <p:spPr/>
-        <p:txBody>
-          <a:bodyPr/>
-          <a:lstStyle/>
-          <a:p>
-            <a:pPr>
-              <a:buNone/>
-            </a:pPr>
-            <a:r>
-              <a:t>C</a:t>
-            </a:r>
-          </a:p>
-          <a:p>
-            <a:pPr lvl="1">
-              <a:buNone/>
-            </a:pPr>
-            <a:r>
-              <a:t>CC</a:t>
-            </a:r>
-          </a:p>
-        </p:txBody>
-      </p:sp>
-      <p:pic>
-        <p:nvPicPr>
-          <p:cNvPr id="6" name="Picture Placeholder 5" descr="image.png"/>
-          <p:cNvPicPr>
-            <a:picLocks noGrp="1" noChangeAspect="1"/>
-          </p:cNvPicPr>
-          <p:nvPr>
-            <p:ph type="pic" idx="16"/>
-          </p:nvPr>
-        </p:nvPicPr>
-        <p:blipFill>
-          <a:blip r:embed="rId2"/>
-          <a:srcRect t="19062" b="19062"/>
-          <a:stretch>
-            <a:fillRect/>
-          </a:stretch>
-        </p:blipFill>
-        <p:spPr/>
-      </p:pic>
-      <p:pic>
-        <p:nvPicPr>
-          <p:cNvPr id="7" name="Picture Placeholder 6" descr="image.png"/>
-          <p:cNvPicPr>
-            <a:picLocks noGrp="1" noChangeAspect="1"/>
-          </p:cNvPicPr>
-          <p:nvPr>
-            <p:ph type="pic" idx="17"/>
-          </p:nvPr>
-        </p:nvPicPr>
-        <p:blipFill>
-          <a:blip r:embed="rId2"/>
-          <a:srcRect t="19062" b="19062"/>
-          <a:stretch>
-            <a:fillRect/>
-          </a:stretch>
-        </p:blipFill>
-        <p:spPr/>
-      </p:pic>
-      <p:pic>
-        <p:nvPicPr>
-          <p:cNvPr id="8" name="Picture Placeholder 7" descr="image.png"/>
-          <p:cNvPicPr>
-            <a:picLocks noGrp="1" noChangeAspect="1"/>
-          </p:cNvPicPr>
-          <p:nvPr>
-            <p:ph type="pic" idx="18"/>
-          </p:nvPr>
-        </p:nvPicPr>
-        <p:blipFill>
-          <a:blip r:embed="rId2"/>
-          <a:srcRect t="19062" b="19062"/>
-          <a:stretch>
-            <a:fillRect/>
-          </a:stretch>
-        </p:blipFill>
-        <p:spPr/>
-      </p:pic>
+              <a:t>Thanks</a:t>
+            </a:r>
+          </a:p>
+        </p:txBody>
+      </p:sp>
     </p:spTree>
   </p:cSld>
   <p:clrMapOvr>
@@ -8097,182 +5927,31 @@
               <a:buNone/>
             </a:pPr>
             <a:r>
-              <a:t>Timeline</a:t>
-            </a:r>
-          </a:p>
-        </p:txBody>
-      </p:sp>
-      <p:sp>
-        <p:nvSpPr>
-          <p:cNvPr id="3" name="Content Placeholder 2"/>
-          <p:cNvSpPr>
-            <a:spLocks noGrp="1"/>
-          </p:cNvSpPr>
-          <p:nvPr>
-            <p:ph idx="13" sz="quarter"/>
-          </p:nvPr>
-        </p:nvSpPr>
-        <p:spPr/>
-        <p:txBody>
-          <a:bodyPr/>
-          <a:lstStyle/>
-          <a:p>
-            <a:pPr lvl="1">
-              <a:buNone/>
-            </a:pPr>
-            <a:r>
-              <a:t>Q1</a:t>
-            </a:r>
-          </a:p>
-          <a:p>
-            <a:pPr>
-              <a:buNone/>
-            </a:pPr>
-            <a:r>
-              <a:t>Plan</a:t>
-            </a:r>
-          </a:p>
-          <a:p>
-            <a:pPr lvl="1">
-              <a:buNone/>
-            </a:pPr>
-            <a:r>
-              <a:t>Start</a:t>
-            </a:r>
-          </a:p>
-        </p:txBody>
-      </p:sp>
-      <p:sp>
-        <p:nvSpPr>
-          <p:cNvPr id="4" name="Content Placeholder 3"/>
-          <p:cNvSpPr>
-            <a:spLocks noGrp="1"/>
-          </p:cNvSpPr>
-          <p:nvPr>
-            <p:ph idx="14" sz="quarter"/>
-          </p:nvPr>
-        </p:nvSpPr>
-        <p:spPr/>
-        <p:txBody>
-          <a:bodyPr/>
-          <a:lstStyle/>
-          <a:p>
-            <a:pPr lvl="1">
-              <a:buNone/>
-            </a:pPr>
-            <a:r>
-              <a:t>Q2</a:t>
-            </a:r>
-          </a:p>
-          <a:p>
-            <a:pPr>
-              <a:buNone/>
-            </a:pPr>
-            <a:r>
-              <a:t>Build</a:t>
-            </a:r>
-          </a:p>
-          <a:p>
-            <a:pPr lvl="1">
-              <a:buNone/>
-            </a:pPr>
-            <a:r>
-              <a:t>Execute</a:t>
-            </a:r>
-          </a:p>
-        </p:txBody>
-      </p:sp>
-      <p:sp>
-        <p:nvSpPr>
-          <p:cNvPr id="5" name="Content Placeholder 4"/>
-          <p:cNvSpPr>
-            <a:spLocks noGrp="1"/>
-          </p:cNvSpPr>
-          <p:nvPr>
-            <p:ph idx="15" sz="quarter"/>
-          </p:nvPr>
-        </p:nvSpPr>
-        <p:spPr/>
-        <p:txBody>
-          <a:bodyPr/>
-          <a:lstStyle/>
-          <a:p>
-            <a:pPr lvl="1">
-              <a:buNone/>
-            </a:pPr>
-            <a:r>
-              <a:t>Q3</a:t>
-            </a:r>
-          </a:p>
-          <a:p>
-            <a:pPr>
-              <a:buNone/>
-            </a:pPr>
-            <a:r>
-              <a:t>Launch</a:t>
-            </a:r>
-          </a:p>
-          <a:p>
-            <a:pPr lvl="1">
-              <a:buNone/>
-            </a:pPr>
-            <a:r>
-              <a:t>Expand</a:t>
-            </a:r>
-          </a:p>
-        </p:txBody>
-      </p:sp>
-      <p:sp>
-        <p:nvSpPr>
-          <p:cNvPr id="6" name="Content Placeholder 5"/>
-          <p:cNvSpPr>
-            <a:spLocks noGrp="1"/>
-          </p:cNvSpPr>
-          <p:nvPr>
-            <p:ph idx="16" sz="quarter"/>
-          </p:nvPr>
-        </p:nvSpPr>
-        <p:spPr/>
-        <p:txBody>
-          <a:bodyPr/>
-          <a:lstStyle/>
-          <a:p/>
-        </p:txBody>
-      </p:sp>
-      <p:sp>
-        <p:nvSpPr>
-          <p:cNvPr id="7" name="Content Placeholder 6"/>
-          <p:cNvSpPr>
-            <a:spLocks noGrp="1"/>
-          </p:cNvSpPr>
-          <p:nvPr>
-            <p:ph idx="17" sz="quarter"/>
-          </p:nvPr>
-        </p:nvSpPr>
-        <p:spPr/>
-        <p:txBody>
-          <a:bodyPr/>
-          <a:lstStyle/>
-          <a:p/>
-        </p:txBody>
-      </p:sp>
-      <p:sp>
-        <p:nvSpPr>
-          <p:cNvPr id="8" name="Content Placeholder 7"/>
-          <p:cNvSpPr>
-            <a:spLocks noGrp="1"/>
-          </p:cNvSpPr>
-          <p:nvPr>
-            <p:ph idx="18" sz="quarter"/>
-          </p:nvPr>
-        </p:nvSpPr>
-        <p:spPr/>
-        <p:txBody>
-          <a:bodyPr/>
-          <a:lstStyle/>
-          <a:p/>
-        </p:txBody>
-      </p:sp>
+              <a:t>Chart</a:t>
+            </a:r>
+          </a:p>
+        </p:txBody>
+      </p:sp>
+      <p:graphicFrame>
+        <p:nvGraphicFramePr>
+          <p:cNvPr id="3" name="Chart Placeholder 2"/>
+          <p:cNvGraphicFramePr>
+            <a:graphicFrameLocks noGrp="1"/>
+          </p:cNvGraphicFramePr>
+          <p:nvPr>
+            <p:ph type="chart" idx="13" sz="quarter"/>
+          </p:nvPr>
+        </p:nvGraphicFramePr>
+        <p:xfrm>
+          <a:off x="426720" y="1405890"/>
+          <a:ext cx="11338560" cy="4286250"/>
+        </p:xfrm>
+        <a:graphic>
+          <a:graphicData uri="http://schemas.openxmlformats.org/drawingml/2006/chart">
+            <c:chart xmlns:c="http://schemas.openxmlformats.org/drawingml/2006/chart" r:id="rId2"/>
+          </a:graphicData>
+        </a:graphic>
+      </p:graphicFrame>
     </p:spTree>
   </p:cSld>
   <p:clrMapOvr>

</xml_diff>